<commit_message>
Auto-copy: Updated files from source repo (nicolaspichon-git/jedha-data-scientist-lead-material)
</commit_message>
<xml_diff>
--- a/deliverables/spotify-step-4-presentation.pptx
+++ b/deliverables/spotify-step-4-presentation.pptx
@@ -688,11 +688,11 @@
         </c:ser>
         <c:gapWidth val="35"/>
         <c:overlap val="0"/>
-        <c:axId val="13823998"/>
-        <c:axId val="57730765"/>
+        <c:axId val="35365928"/>
+        <c:axId val="96027286"/>
       </c:barChart>
       <c:catAx>
-        <c:axId val="13823998"/>
+        <c:axId val="35365928"/>
         <c:scaling>
           <c:orientation val="minMax"/>
         </c:scaling>
@@ -726,7 +726,7 @@
             </a:pPr>
           </a:p>
         </c:txPr>
-        <c:crossAx val="57730765"/>
+        <c:crossAx val="96027286"/>
         <c:crosses val="autoZero"/>
         <c:auto val="1"/>
         <c:lblAlgn val="ctr"/>
@@ -734,7 +734,7 @@
         <c:noMultiLvlLbl val="0"/>
       </c:catAx>
       <c:valAx>
-        <c:axId val="57730765"/>
+        <c:axId val="96027286"/>
         <c:scaling>
           <c:orientation val="minMax"/>
           <c:max val="5"/>
@@ -780,7 +780,7 @@
             </a:pPr>
           </a:p>
         </c:txPr>
-        <c:crossAx val="13823998"/>
+        <c:crossAx val="35365928"/>
         <c:crosses val="autoZero"/>
         <c:crossBetween val="between"/>
         <c:majorUnit val="1"/>
@@ -1371,7 +1371,7 @@
             <a:pPr indent="0" algn="r">
               <a:buNone/>
             </a:pPr>
-            <a:fld id="{F5D2A813-7351-433B-A0D0-E3C6CDDB5123}" type="slidenum">
+            <a:fld id="{9D970C4D-5717-42F9-9E95-C5BBAA446028}" type="slidenum">
               <a:rPr lang="fr-FR" sz="1400" b="0" u="none" strike="noStrike">
                 <a:solidFill>
                   <a:srgbClr val="000000"/>
@@ -1429,7 +1429,7 @@
         <p:spPr>
           <a:xfrm>
             <a:off x="685800" y="1143000"/>
-            <a:ext cx="5483880" cy="3083760"/>
+            <a:ext cx="5483520" cy="3083400"/>
           </a:xfrm>
           <a:prstGeom prst="rect">
             <a:avLst/>
@@ -1452,7 +1452,7 @@
         <p:spPr>
           <a:xfrm>
             <a:off x="685800" y="4400640"/>
-            <a:ext cx="5483880" cy="3597840"/>
+            <a:ext cx="5483520" cy="3597480"/>
           </a:xfrm>
           <a:prstGeom prst="rect">
             <a:avLst/>
@@ -1704,7 +1704,7 @@
         <p:spPr>
           <a:xfrm>
             <a:off x="3884760" y="8685360"/>
-            <a:ext cx="2969280" cy="456120"/>
+            <a:ext cx="2968920" cy="455760"/>
           </a:xfrm>
           <a:prstGeom prst="rect">
             <a:avLst/>
@@ -1748,7 +1748,7 @@
                 <a:tab pos="0" algn="l"/>
               </a:tabLst>
             </a:pPr>
-            <a:fld id="{4EF10CFA-CF55-4FE2-9F26-DB19A7816BEB}" type="slidenum">
+            <a:fld id="{625B30C3-9993-435C-9A37-AE5DC2E498A1}" type="slidenum">
               <a:rPr lang="fr-FR" sz="1200" b="0" u="none" strike="noStrike">
                 <a:solidFill>
                   <a:schemeClr val="dk1"/>
@@ -1806,7 +1806,7 @@
         <p:spPr>
           <a:xfrm>
             <a:off x="685800" y="1143000"/>
-            <a:ext cx="5483880" cy="3083760"/>
+            <a:ext cx="5483520" cy="3083400"/>
           </a:xfrm>
           <a:prstGeom prst="rect">
             <a:avLst/>
@@ -1829,7 +1829,7 @@
         <p:spPr>
           <a:xfrm>
             <a:off x="685800" y="4400640"/>
-            <a:ext cx="5483880" cy="3597840"/>
+            <a:ext cx="5483520" cy="3597480"/>
           </a:xfrm>
           <a:prstGeom prst="rect">
             <a:avLst/>
@@ -2106,7 +2106,7 @@
         <p:spPr>
           <a:xfrm>
             <a:off x="3884760" y="8685360"/>
-            <a:ext cx="2969280" cy="456120"/>
+            <a:ext cx="2968920" cy="455760"/>
           </a:xfrm>
           <a:prstGeom prst="rect">
             <a:avLst/>
@@ -2150,7 +2150,7 @@
                 <a:tab pos="0" algn="l"/>
               </a:tabLst>
             </a:pPr>
-            <a:fld id="{2A32BB3F-001D-4312-835F-B59081A76AE0}" type="slidenum">
+            <a:fld id="{A8B1E20F-1E13-456D-9BAC-7D6603AAAA1D}" type="slidenum">
               <a:rPr lang="fr-FR" sz="1200" b="0" u="none" strike="noStrike">
                 <a:solidFill>
                   <a:schemeClr val="dk1"/>
@@ -2208,7 +2208,7 @@
         <p:spPr>
           <a:xfrm>
             <a:off x="685800" y="1143000"/>
-            <a:ext cx="5483880" cy="3083760"/>
+            <a:ext cx="5483520" cy="3083400"/>
           </a:xfrm>
           <a:prstGeom prst="rect">
             <a:avLst/>
@@ -2231,7 +2231,7 @@
         <p:spPr>
           <a:xfrm>
             <a:off x="685800" y="4500000"/>
-            <a:ext cx="5483880" cy="5759640"/>
+            <a:ext cx="5483520" cy="5759280"/>
           </a:xfrm>
           <a:prstGeom prst="rect">
             <a:avLst/>
@@ -2615,7 +2615,7 @@
         <p:spPr>
           <a:xfrm>
             <a:off x="3884760" y="8685360"/>
-            <a:ext cx="2969280" cy="456120"/>
+            <a:ext cx="2968920" cy="455760"/>
           </a:xfrm>
           <a:prstGeom prst="rect">
             <a:avLst/>
@@ -2659,7 +2659,7 @@
                 <a:tab pos="0" algn="l"/>
               </a:tabLst>
             </a:pPr>
-            <a:fld id="{3643A1E2-D2EF-4565-A781-7BCC3B0066EC}" type="slidenum">
+            <a:fld id="{93ABF75F-FAA8-48DF-B777-91A037EBC4FA}" type="slidenum">
               <a:rPr lang="fr-FR" sz="1200" b="0" u="none" strike="noStrike">
                 <a:solidFill>
                   <a:schemeClr val="dk1"/>
@@ -2717,7 +2717,7 @@
         <p:spPr>
           <a:xfrm>
             <a:off x="685800" y="1143000"/>
-            <a:ext cx="5483880" cy="3083760"/>
+            <a:ext cx="5483520" cy="3083400"/>
           </a:xfrm>
           <a:prstGeom prst="rect">
             <a:avLst/>
@@ -2740,7 +2740,7 @@
         <p:spPr>
           <a:xfrm>
             <a:off x="685800" y="4400640"/>
-            <a:ext cx="5483880" cy="3879000"/>
+            <a:ext cx="5483520" cy="3878640"/>
           </a:xfrm>
           <a:prstGeom prst="rect">
             <a:avLst/>
@@ -3088,7 +3088,7 @@
         <p:spPr>
           <a:xfrm>
             <a:off x="3884760" y="8685360"/>
-            <a:ext cx="2969280" cy="456120"/>
+            <a:ext cx="2968920" cy="455760"/>
           </a:xfrm>
           <a:prstGeom prst="rect">
             <a:avLst/>
@@ -3132,7 +3132,7 @@
                 <a:tab pos="0" algn="l"/>
               </a:tabLst>
             </a:pPr>
-            <a:fld id="{A2829473-A762-484B-AD43-1EC7315EBC71}" type="slidenum">
+            <a:fld id="{1F2B0A34-B2F5-401D-A63A-48C36F76162F}" type="slidenum">
               <a:rPr lang="fr-FR" sz="1200" b="0" u="none" strike="noStrike">
                 <a:solidFill>
                   <a:schemeClr val="dk1"/>
@@ -3190,7 +3190,7 @@
         <p:spPr>
           <a:xfrm>
             <a:off x="685800" y="1143000"/>
-            <a:ext cx="5483880" cy="3083760"/>
+            <a:ext cx="5483520" cy="3083400"/>
           </a:xfrm>
           <a:prstGeom prst="rect">
             <a:avLst/>
@@ -3213,7 +3213,7 @@
         <p:spPr>
           <a:xfrm>
             <a:off x="685800" y="4400640"/>
-            <a:ext cx="5483880" cy="4059000"/>
+            <a:ext cx="5483520" cy="4058640"/>
           </a:xfrm>
           <a:prstGeom prst="rect">
             <a:avLst/>
@@ -3631,7 +3631,7 @@
         <p:spPr>
           <a:xfrm>
             <a:off x="3884760" y="8685360"/>
-            <a:ext cx="2969280" cy="456120"/>
+            <a:ext cx="2968920" cy="455760"/>
           </a:xfrm>
           <a:prstGeom prst="rect">
             <a:avLst/>
@@ -3675,7 +3675,7 @@
                 <a:tab pos="0" algn="l"/>
               </a:tabLst>
             </a:pPr>
-            <a:fld id="{27ED33FA-8C1F-435B-A4D0-98D4CB2F9F4D}" type="slidenum">
+            <a:fld id="{48539DF2-35EA-4CA4-9C01-068F11A35D78}" type="slidenum">
               <a:rPr lang="fr-FR" sz="1200" b="0" u="none" strike="noStrike">
                 <a:solidFill>
                   <a:schemeClr val="dk1"/>
@@ -3733,7 +3733,7 @@
         <p:spPr>
           <a:xfrm>
             <a:off x="685800" y="1143000"/>
-            <a:ext cx="5483880" cy="3083760"/>
+            <a:ext cx="5483520" cy="3083400"/>
           </a:xfrm>
           <a:prstGeom prst="rect">
             <a:avLst/>
@@ -3756,7 +3756,7 @@
         <p:spPr>
           <a:xfrm>
             <a:off x="685800" y="4400640"/>
-            <a:ext cx="5483880" cy="5499000"/>
+            <a:ext cx="5483520" cy="5498640"/>
           </a:xfrm>
           <a:prstGeom prst="rect">
             <a:avLst/>
@@ -4175,7 +4175,7 @@
         <p:spPr>
           <a:xfrm>
             <a:off x="3884760" y="8685360"/>
-            <a:ext cx="2969280" cy="456120"/>
+            <a:ext cx="2968920" cy="455760"/>
           </a:xfrm>
           <a:prstGeom prst="rect">
             <a:avLst/>
@@ -4219,7 +4219,7 @@
                 <a:tab pos="0" algn="l"/>
               </a:tabLst>
             </a:pPr>
-            <a:fld id="{F9DD7147-6B70-4072-8002-D387407C4AE7}" type="slidenum">
+            <a:fld id="{5CD7961F-CCC1-4399-B7FD-F25D17AE70D5}" type="slidenum">
               <a:rPr lang="fr-FR" sz="1200" b="0" u="none" strike="noStrike">
                 <a:solidFill>
                   <a:schemeClr val="dk1"/>
@@ -4277,7 +4277,7 @@
         <p:spPr>
           <a:xfrm>
             <a:off x="685800" y="1143000"/>
-            <a:ext cx="5483880" cy="3083760"/>
+            <a:ext cx="5483520" cy="3083400"/>
           </a:xfrm>
           <a:prstGeom prst="rect">
             <a:avLst/>
@@ -4300,7 +4300,7 @@
         <p:spPr>
           <a:xfrm>
             <a:off x="685800" y="4400640"/>
-            <a:ext cx="5483880" cy="4239000"/>
+            <a:ext cx="5483520" cy="4238640"/>
           </a:xfrm>
           <a:prstGeom prst="rect">
             <a:avLst/>
@@ -4661,7 +4661,7 @@
         <p:spPr>
           <a:xfrm>
             <a:off x="3884760" y="8685360"/>
-            <a:ext cx="2969280" cy="456120"/>
+            <a:ext cx="2968920" cy="455760"/>
           </a:xfrm>
           <a:prstGeom prst="rect">
             <a:avLst/>
@@ -4705,7 +4705,7 @@
                 <a:tab pos="0" algn="l"/>
               </a:tabLst>
             </a:pPr>
-            <a:fld id="{7950666F-8E82-4210-BA04-998153BEAE7E}" type="slidenum">
+            <a:fld id="{E6342FCA-0EFC-487C-B430-C0240C2DEA7E}" type="slidenum">
               <a:rPr lang="fr-FR" sz="1200" b="0" u="none" strike="noStrike">
                 <a:solidFill>
                   <a:schemeClr val="dk1"/>
@@ -4763,7 +4763,7 @@
         <p:spPr>
           <a:xfrm>
             <a:off x="685800" y="1143000"/>
-            <a:ext cx="5483880" cy="3083760"/>
+            <a:ext cx="5483520" cy="3083400"/>
           </a:xfrm>
           <a:prstGeom prst="rect">
             <a:avLst/>
@@ -4786,7 +4786,7 @@
         <p:spPr>
           <a:xfrm>
             <a:off x="685800" y="4400640"/>
-            <a:ext cx="5483880" cy="3879000"/>
+            <a:ext cx="5483520" cy="3878640"/>
           </a:xfrm>
           <a:prstGeom prst="rect">
             <a:avLst/>
@@ -5028,7 +5028,7 @@
         <p:spPr>
           <a:xfrm>
             <a:off x="3884760" y="8685360"/>
-            <a:ext cx="2969280" cy="456120"/>
+            <a:ext cx="2968920" cy="455760"/>
           </a:xfrm>
           <a:prstGeom prst="rect">
             <a:avLst/>
@@ -5072,7 +5072,7 @@
                 <a:tab pos="0" algn="l"/>
               </a:tabLst>
             </a:pPr>
-            <a:fld id="{FBB22790-DD7F-4BF1-8005-756010DB58A3}" type="slidenum">
+            <a:fld id="{B4BF43DD-B7D1-42E0-97DD-3E6E4EB9A6BE}" type="slidenum">
               <a:rPr lang="fr-FR" sz="1200" b="0" u="none" strike="noStrike">
                 <a:solidFill>
                   <a:schemeClr val="dk1"/>
@@ -5130,7 +5130,7 @@
         <p:spPr>
           <a:xfrm>
             <a:off x="685800" y="1143000"/>
-            <a:ext cx="5483880" cy="3083760"/>
+            <a:ext cx="5483520" cy="3083400"/>
           </a:xfrm>
           <a:prstGeom prst="rect">
             <a:avLst/>
@@ -5153,7 +5153,7 @@
         <p:spPr>
           <a:xfrm>
             <a:off x="685800" y="4400640"/>
-            <a:ext cx="5483880" cy="3597840"/>
+            <a:ext cx="5483520" cy="3597480"/>
           </a:xfrm>
           <a:prstGeom prst="rect">
             <a:avLst/>
@@ -5556,7 +5556,7 @@
         <p:spPr>
           <a:xfrm>
             <a:off x="3884760" y="8685360"/>
-            <a:ext cx="2969280" cy="456120"/>
+            <a:ext cx="2968920" cy="455760"/>
           </a:xfrm>
           <a:prstGeom prst="rect">
             <a:avLst/>
@@ -5600,7 +5600,7 @@
                 <a:tab pos="0" algn="l"/>
               </a:tabLst>
             </a:pPr>
-            <a:fld id="{5784B3CB-ABB1-475D-84E7-C21E58499A83}" type="slidenum">
+            <a:fld id="{2F433FDC-BDDF-44CE-A861-65476ABAFB59}" type="slidenum">
               <a:rPr lang="fr-FR" sz="1200" b="0" u="none" strike="noStrike">
                 <a:solidFill>
                   <a:schemeClr val="dk1"/>
@@ -5658,7 +5658,7 @@
         <p:spPr>
           <a:xfrm>
             <a:off x="685800" y="1143000"/>
-            <a:ext cx="5483880" cy="3083760"/>
+            <a:ext cx="5483520" cy="3083400"/>
           </a:xfrm>
           <a:prstGeom prst="rect">
             <a:avLst/>
@@ -5681,7 +5681,7 @@
         <p:spPr>
           <a:xfrm>
             <a:off x="685800" y="4400640"/>
-            <a:ext cx="5483880" cy="5319000"/>
+            <a:ext cx="5483520" cy="5318640"/>
           </a:xfrm>
           <a:prstGeom prst="rect">
             <a:avLst/>
@@ -6077,7 +6077,7 @@
         <p:spPr>
           <a:xfrm>
             <a:off x="3884760" y="8685360"/>
-            <a:ext cx="2969280" cy="456120"/>
+            <a:ext cx="2968920" cy="455760"/>
           </a:xfrm>
           <a:prstGeom prst="rect">
             <a:avLst/>
@@ -6121,7 +6121,7 @@
                 <a:tab pos="0" algn="l"/>
               </a:tabLst>
             </a:pPr>
-            <a:fld id="{A75B8904-9C18-4A22-879F-4A85EADAD9B0}" type="slidenum">
+            <a:fld id="{44948C21-6C18-432D-8E2C-45A92C8AC397}" type="slidenum">
               <a:rPr lang="fr-FR" sz="1200" b="0" u="none" strike="noStrike">
                 <a:solidFill>
                   <a:schemeClr val="dk1"/>
@@ -6186,7 +6186,7 @@
         <p:spPr>
           <a:xfrm>
             <a:off x="609480" y="510480"/>
-            <a:ext cx="10971720" cy="670680"/>
+            <a:ext cx="10971360" cy="670680"/>
           </a:xfrm>
           <a:prstGeom prst="rect">
             <a:avLst/>
@@ -6264,7 +6264,7 @@
         <p:spPr>
           <a:xfrm>
             <a:off x="609480" y="1604520"/>
-            <a:ext cx="10972080" cy="3976920"/>
+            <a:ext cx="10971720" cy="3976560"/>
           </a:xfrm>
           <a:prstGeom prst="rect">
             <a:avLst/>
@@ -6723,7 +6723,7 @@
         <p:spPr>
           <a:xfrm>
             <a:off x="609480" y="273600"/>
-            <a:ext cx="10972080" cy="1144440"/>
+            <a:ext cx="10971720" cy="1144080"/>
           </a:xfrm>
           <a:prstGeom prst="rect">
             <a:avLst/>
@@ -6801,7 +6801,7 @@
         <p:spPr>
           <a:xfrm>
             <a:off x="609480" y="1604520"/>
-            <a:ext cx="10972080" cy="3976920"/>
+            <a:ext cx="10971720" cy="3976560"/>
           </a:xfrm>
           <a:prstGeom prst="rect">
             <a:avLst/>
@@ -7283,7 +7283,7 @@
         <p:spPr>
           <a:xfrm>
             <a:off x="640080" y="685800"/>
-            <a:ext cx="8227080" cy="317520"/>
+            <a:ext cx="8226720" cy="317160"/>
           </a:xfrm>
           <a:prstGeom prst="rect">
             <a:avLst/>
@@ -7344,7 +7344,7 @@
         <p:spPr>
           <a:xfrm>
             <a:off x="640080" y="1417320"/>
-            <a:ext cx="8501400" cy="1551960"/>
+            <a:ext cx="8501040" cy="1551600"/>
           </a:xfrm>
           <a:prstGeom prst="rect">
             <a:avLst/>
@@ -7405,7 +7405,7 @@
         <p:spPr>
           <a:xfrm>
             <a:off x="640080" y="2880360"/>
-            <a:ext cx="7861320" cy="637560"/>
+            <a:ext cx="7860960" cy="637200"/>
           </a:xfrm>
           <a:prstGeom prst="rect">
             <a:avLst/>
@@ -7466,7 +7466,7 @@
         <p:spPr>
           <a:xfrm>
             <a:off x="640080" y="4160520"/>
-            <a:ext cx="2374920" cy="683280"/>
+            <a:ext cx="2374560" cy="682920"/>
           </a:xfrm>
           <a:prstGeom prst="rect">
             <a:avLst/>
@@ -7527,7 +7527,7 @@
         <p:spPr>
           <a:xfrm>
             <a:off x="640080" y="4818960"/>
-            <a:ext cx="2374920" cy="363240"/>
+            <a:ext cx="2374560" cy="362880"/>
           </a:xfrm>
           <a:prstGeom prst="rect">
             <a:avLst/>
@@ -7588,7 +7588,7 @@
         <p:spPr>
           <a:xfrm>
             <a:off x="3337560" y="4160520"/>
-            <a:ext cx="2374920" cy="683280"/>
+            <a:ext cx="2374560" cy="682920"/>
           </a:xfrm>
           <a:prstGeom prst="rect">
             <a:avLst/>
@@ -7649,7 +7649,7 @@
         <p:spPr>
           <a:xfrm>
             <a:off x="3337560" y="4818960"/>
-            <a:ext cx="2374920" cy="363240"/>
+            <a:ext cx="2374560" cy="362880"/>
           </a:xfrm>
           <a:prstGeom prst="rect">
             <a:avLst/>
@@ -7710,7 +7710,7 @@
         <p:spPr>
           <a:xfrm>
             <a:off x="6035040" y="4160520"/>
-            <a:ext cx="2374920" cy="683280"/>
+            <a:ext cx="2374560" cy="682920"/>
           </a:xfrm>
           <a:prstGeom prst="rect">
             <a:avLst/>
@@ -7771,7 +7771,7 @@
         <p:spPr>
           <a:xfrm>
             <a:off x="6035040" y="4818960"/>
-            <a:ext cx="2374920" cy="363240"/>
+            <a:ext cx="2374560" cy="362880"/>
           </a:xfrm>
           <a:prstGeom prst="rect">
             <a:avLst/>
@@ -7832,7 +7832,7 @@
         <p:spPr>
           <a:xfrm>
             <a:off x="640080" y="6355080"/>
-            <a:ext cx="7312680" cy="271800"/>
+            <a:ext cx="7312320" cy="271440"/>
           </a:xfrm>
           <a:prstGeom prst="rect">
             <a:avLst/>
@@ -7893,7 +7893,7 @@
         <p:spPr>
           <a:xfrm>
             <a:off x="11003040" y="6355080"/>
-            <a:ext cx="820440" cy="271800"/>
+            <a:ext cx="820080" cy="271440"/>
           </a:xfrm>
           <a:prstGeom prst="rect">
             <a:avLst/>
@@ -7991,7 +7991,7 @@
         <p:spPr>
           <a:xfrm>
             <a:off x="548640" y="384120"/>
-            <a:ext cx="7312680" cy="290160"/>
+            <a:ext cx="7312320" cy="289800"/>
           </a:xfrm>
           <a:prstGeom prst="rect">
             <a:avLst/>
@@ -8052,7 +8052,7 @@
         <p:spPr>
           <a:xfrm>
             <a:off x="548640" y="658440"/>
-            <a:ext cx="10429560" cy="866160"/>
+            <a:ext cx="10429200" cy="865800"/>
           </a:xfrm>
           <a:prstGeom prst="rect">
             <a:avLst/>
@@ -8117,7 +8117,7 @@
         <p:spPr>
           <a:xfrm>
             <a:off x="11140200" y="365760"/>
-            <a:ext cx="655920" cy="655920"/>
+            <a:ext cx="655560" cy="655560"/>
           </a:xfrm>
           <a:prstGeom prst="rect">
             <a:avLst/>
@@ -8141,7 +8141,7 @@
         <p:spPr>
           <a:xfrm>
             <a:off x="1531800" y="1783080"/>
-            <a:ext cx="637560" cy="637560"/>
+            <a:ext cx="637200" cy="637200"/>
           </a:xfrm>
           <a:prstGeom prst="rect">
             <a:avLst/>
@@ -8161,7 +8161,7 @@
         <p:spPr>
           <a:xfrm>
             <a:off x="548640" y="2560320"/>
-            <a:ext cx="2603520" cy="317520"/>
+            <a:ext cx="2603160" cy="317160"/>
           </a:xfrm>
           <a:prstGeom prst="rect">
             <a:avLst/>
@@ -8222,7 +8222,7 @@
         <p:spPr>
           <a:xfrm>
             <a:off x="548640" y="2880360"/>
-            <a:ext cx="2860200" cy="911880"/>
+            <a:ext cx="2859840" cy="911520"/>
           </a:xfrm>
           <a:prstGeom prst="rect">
             <a:avLst/>
@@ -8317,7 +8317,7 @@
         <p:spPr>
           <a:xfrm>
             <a:off x="4393800" y="1783080"/>
-            <a:ext cx="637560" cy="637560"/>
+            <a:ext cx="637200" cy="637200"/>
           </a:xfrm>
           <a:prstGeom prst="rect">
             <a:avLst/>
@@ -8337,7 +8337,7 @@
         <p:spPr>
           <a:xfrm>
             <a:off x="3410640" y="2560320"/>
-            <a:ext cx="2603520" cy="317520"/>
+            <a:ext cx="2603160" cy="317160"/>
           </a:xfrm>
           <a:prstGeom prst="rect">
             <a:avLst/>
@@ -8398,7 +8398,7 @@
         <p:spPr>
           <a:xfrm>
             <a:off x="3410640" y="2880360"/>
-            <a:ext cx="2603520" cy="911880"/>
+            <a:ext cx="2603160" cy="911520"/>
           </a:xfrm>
           <a:prstGeom prst="rect">
             <a:avLst/>
@@ -8493,7 +8493,7 @@
         <p:spPr>
           <a:xfrm>
             <a:off x="7255800" y="1783080"/>
-            <a:ext cx="637560" cy="637560"/>
+            <a:ext cx="637200" cy="637200"/>
           </a:xfrm>
           <a:prstGeom prst="rect">
             <a:avLst/>
@@ -8513,7 +8513,7 @@
         <p:spPr>
           <a:xfrm>
             <a:off x="6272640" y="2560320"/>
-            <a:ext cx="2603520" cy="317520"/>
+            <a:ext cx="2603160" cy="317160"/>
           </a:xfrm>
           <a:prstGeom prst="rect">
             <a:avLst/>
@@ -8574,7 +8574,7 @@
         <p:spPr>
           <a:xfrm>
             <a:off x="6272640" y="2880360"/>
-            <a:ext cx="2603520" cy="911880"/>
+            <a:ext cx="2603160" cy="911520"/>
           </a:xfrm>
           <a:prstGeom prst="rect">
             <a:avLst/>
@@ -8639,7 +8639,7 @@
         <p:spPr>
           <a:xfrm>
             <a:off x="10117800" y="1783080"/>
-            <a:ext cx="637560" cy="637560"/>
+            <a:ext cx="637200" cy="637200"/>
           </a:xfrm>
           <a:prstGeom prst="rect">
             <a:avLst/>
@@ -8659,7 +8659,7 @@
         <p:spPr>
           <a:xfrm>
             <a:off x="9135000" y="2560320"/>
-            <a:ext cx="2603520" cy="317520"/>
+            <a:ext cx="2603160" cy="317160"/>
           </a:xfrm>
           <a:prstGeom prst="rect">
             <a:avLst/>
@@ -8720,7 +8720,7 @@
         <p:spPr>
           <a:xfrm>
             <a:off x="9135000" y="2880360"/>
-            <a:ext cx="2603520" cy="911880"/>
+            <a:ext cx="2603160" cy="911520"/>
           </a:xfrm>
           <a:prstGeom prst="rect">
             <a:avLst/>
@@ -8811,7 +8811,7 @@
         <p:spPr>
           <a:xfrm>
             <a:off x="548640" y="4160520"/>
-            <a:ext cx="11089080" cy="1872000"/>
+            <a:ext cx="11088720" cy="1871640"/>
           </a:xfrm>
           <a:prstGeom prst="roundRect">
             <a:avLst>
@@ -8859,7 +8859,7 @@
         <p:spPr>
           <a:xfrm>
             <a:off x="868680" y="4280040"/>
-            <a:ext cx="5483880" cy="317520"/>
+            <a:ext cx="5483520" cy="317160"/>
           </a:xfrm>
           <a:prstGeom prst="rect">
             <a:avLst/>
@@ -8920,7 +8920,7 @@
         <p:spPr>
           <a:xfrm>
             <a:off x="868680" y="4681800"/>
-            <a:ext cx="10421640" cy="1231920"/>
+            <a:ext cx="10421280" cy="1231560"/>
           </a:xfrm>
           <a:prstGeom prst="rect">
             <a:avLst/>
@@ -9199,7 +9199,7 @@
         <p:spPr>
           <a:xfrm>
             <a:off x="548640" y="6473880"/>
-            <a:ext cx="7312680" cy="271800"/>
+            <a:ext cx="7312320" cy="271440"/>
           </a:xfrm>
           <a:prstGeom prst="rect">
             <a:avLst/>
@@ -9260,7 +9260,7 @@
         <p:spPr>
           <a:xfrm>
             <a:off x="11003040" y="6473880"/>
-            <a:ext cx="820440" cy="271800"/>
+            <a:ext cx="820080" cy="271440"/>
           </a:xfrm>
           <a:prstGeom prst="rect">
             <a:avLst/>
@@ -9299,7 +9299,79 @@
                 <a:latin typeface="Calibri"/>
                 <a:ea typeface="Calibri"/>
               </a:rPr>
-              <a:t>10 / 10</a:t>
+              <a:t>1</a:t>
+            </a:r>
+            <a:r>
+              <a:rPr lang="fr-FR" sz="950" b="0" u="none" strike="noStrike">
+                <a:solidFill>
+                  <a:srgbClr val="9FB0C9"/>
+                </a:solidFill>
+                <a:effectLst/>
+                <a:uFillTx/>
+                <a:latin typeface="Calibri"/>
+                <a:ea typeface="Calibri"/>
+              </a:rPr>
+              <a:t>0</a:t>
+            </a:r>
+            <a:r>
+              <a:rPr lang="fr-FR" sz="950" b="0" u="none" strike="noStrike">
+                <a:solidFill>
+                  <a:srgbClr val="9FB0C9"/>
+                </a:solidFill>
+                <a:effectLst/>
+                <a:uFillTx/>
+                <a:latin typeface="Calibri"/>
+                <a:ea typeface="Calibri"/>
+              </a:rPr>
+              <a:t> </a:t>
+            </a:r>
+            <a:r>
+              <a:rPr lang="fr-FR" sz="950" b="0" u="none" strike="noStrike">
+                <a:solidFill>
+                  <a:srgbClr val="9FB0C9"/>
+                </a:solidFill>
+                <a:effectLst/>
+                <a:uFillTx/>
+                <a:latin typeface="Calibri"/>
+                <a:ea typeface="Calibri"/>
+              </a:rPr>
+              <a:t>/</a:t>
+            </a:r>
+            <a:r>
+              <a:rPr lang="fr-FR" sz="950" b="0" u="none" strike="noStrike">
+                <a:solidFill>
+                  <a:srgbClr val="9FB0C9"/>
+                </a:solidFill>
+                <a:effectLst/>
+                <a:uFillTx/>
+                <a:latin typeface="Calibri"/>
+                <a:ea typeface="Calibri"/>
+              </a:rPr>
+              <a:t> </a:t>
+            </a:r>
+            <a:r>
+              <a:rPr lang="fr-FR" sz="950" b="0" u="none" strike="noStrike">
+                <a:solidFill>
+                  <a:srgbClr val="9FB0C9"/>
+                </a:solidFill>
+                <a:effectLst/>
+                <a:uFillTx/>
+                <a:latin typeface="Calibri"/>
+                <a:ea typeface="Calibri"/>
+              </a:rPr>
+              <a:t>1</a:t>
+            </a:r>
+            <a:r>
+              <a:rPr lang="fr-FR" sz="950" b="0" u="none" strike="noStrike">
+                <a:solidFill>
+                  <a:srgbClr val="9FB0C9"/>
+                </a:solidFill>
+                <a:effectLst/>
+                <a:uFillTx/>
+                <a:latin typeface="Calibri"/>
+                <a:ea typeface="Calibri"/>
+              </a:rPr>
+              <a:t>0</a:t>
             </a:r>
             <a:endParaRPr lang="fr-FR" sz="950" b="0" u="none" strike="noStrike">
               <a:solidFill>
@@ -9358,7 +9430,7 @@
         <p:spPr>
           <a:xfrm>
             <a:off x="548640" y="384120"/>
-            <a:ext cx="7312680" cy="290160"/>
+            <a:ext cx="7312320" cy="289800"/>
           </a:xfrm>
           <a:prstGeom prst="rect">
             <a:avLst/>
@@ -9419,7 +9491,7 @@
         <p:spPr>
           <a:xfrm>
             <a:off x="566640" y="658440"/>
-            <a:ext cx="9507240" cy="866160"/>
+            <a:ext cx="9506880" cy="865800"/>
           </a:xfrm>
           <a:prstGeom prst="rect">
             <a:avLst/>
@@ -9458,19 +9530,7 @@
                 <a:latin typeface="Cambria"/>
                 <a:ea typeface="Cambria"/>
               </a:rPr>
-              <a:t>Une maturité data en </a:t>
-            </a:r>
-            <a:r>
-              <a:rPr lang="fr-FR" sz="2800" b="1" u="none" strike="noStrike">
-                <a:solidFill>
-                  <a:srgbClr val="1B2A4A"/>
-                </a:solidFill>
-                <a:effectLst/>
-                <a:uFillTx/>
-                <a:latin typeface="Cambria"/>
-                <a:ea typeface="Cambria"/>
-              </a:rPr>
-              <a:t>phase initiale</a:t>
+              <a:t>Une maturité data en phase initiale</a:t>
             </a:r>
             <a:endParaRPr lang="fr-FR" sz="2800" b="0" u="none" strike="noStrike">
               <a:solidFill>
@@ -9496,7 +9556,7 @@
         <p:spPr>
           <a:xfrm>
             <a:off x="11140200" y="365760"/>
-            <a:ext cx="655920" cy="655920"/>
+            <a:ext cx="655560" cy="655560"/>
           </a:xfrm>
           <a:prstGeom prst="rect">
             <a:avLst/>
@@ -9515,7 +9575,7 @@
         </p:nvGraphicFramePr>
         <p:xfrm>
           <a:off x="502920" y="1691640"/>
-          <a:ext cx="6946920" cy="4478040"/>
+          <a:ext cx="6946560" cy="4477680"/>
         </p:xfrm>
         <a:graphic>
           <a:graphicData uri="http://schemas.openxmlformats.org/drawingml/2006/chart">
@@ -9532,7 +9592,7 @@
         <p:spPr>
           <a:xfrm>
             <a:off x="7560000" y="1691640"/>
-            <a:ext cx="4318200" cy="1414800"/>
+            <a:ext cx="4317840" cy="1414440"/>
           </a:xfrm>
           <a:prstGeom prst="roundRect">
             <a:avLst>
@@ -9587,7 +9647,7 @@
         <p:spPr>
           <a:xfrm>
             <a:off x="9180000" y="1810440"/>
-            <a:ext cx="2518200" cy="637560"/>
+            <a:ext cx="2517840" cy="637200"/>
           </a:xfrm>
           <a:prstGeom prst="rect">
             <a:avLst/>
@@ -9648,7 +9708,7 @@
         <p:spPr>
           <a:xfrm>
             <a:off x="7560000" y="3246120"/>
-            <a:ext cx="4318200" cy="1231920"/>
+            <a:ext cx="4317840" cy="1231560"/>
           </a:xfrm>
           <a:prstGeom prst="roundRect">
             <a:avLst>
@@ -9703,7 +9763,7 @@
         <p:spPr>
           <a:xfrm>
             <a:off x="7740000" y="3364920"/>
-            <a:ext cx="3733200" cy="363240"/>
+            <a:ext cx="3732840" cy="362880"/>
           </a:xfrm>
           <a:prstGeom prst="rect">
             <a:avLst/>
@@ -9764,7 +9824,7 @@
         <p:spPr>
           <a:xfrm>
             <a:off x="7740000" y="3730680"/>
-            <a:ext cx="3958200" cy="591840"/>
+            <a:ext cx="3957840" cy="591480"/>
           </a:xfrm>
           <a:prstGeom prst="rect">
             <a:avLst/>
@@ -9803,8 +9863,26 @@
                 <a:latin typeface="Calibri"/>
                 <a:ea typeface="Calibri"/>
               </a:rPr>
-              <a:t>Gouvernance globale &amp; bien </a:t>
-            </a:r>
+              <a:t>Gouvernance globale &amp; bien définie, </a:t>
+            </a:r>
+            <a:endParaRPr lang="fr-FR" sz="1400" b="0" u="none" strike="noStrike">
+              <a:solidFill>
+                <a:srgbClr val="000000"/>
+              </a:solidFill>
+              <a:effectLst/>
+              <a:uFillTx/>
+              <a:latin typeface="Arial"/>
+            </a:endParaRPr>
+          </a:p>
+          <a:p>
+            <a:pPr defTabSz="914400">
+              <a:lnSpc>
+                <a:spcPct val="100000"/>
+              </a:lnSpc>
+              <a:tabLst>
+                <a:tab pos="0" algn="l"/>
+              </a:tabLst>
+            </a:pPr>
             <a:r>
               <a:rPr lang="fr-FR" sz="1400" b="0" u="none" strike="noStrike">
                 <a:solidFill>
@@ -9815,49 +9893,7 @@
                 <a:latin typeface="Calibri"/>
                 <a:ea typeface="Calibri"/>
               </a:rPr>
-              <a:t>définie, </a:t>
-            </a:r>
-            <a:endParaRPr lang="fr-FR" sz="1400" b="0" u="none" strike="noStrike">
-              <a:solidFill>
-                <a:srgbClr val="000000"/>
-              </a:solidFill>
-              <a:effectLst/>
-              <a:uFillTx/>
-              <a:latin typeface="Arial"/>
-            </a:endParaRPr>
-          </a:p>
-          <a:p>
-            <a:pPr defTabSz="914400">
-              <a:lnSpc>
-                <a:spcPct val="100000"/>
-              </a:lnSpc>
-              <a:tabLst>
-                <a:tab pos="0" algn="l"/>
-              </a:tabLst>
-            </a:pPr>
-            <a:r>
-              <a:rPr lang="fr-FR" sz="1400" b="0" u="none" strike="noStrike">
-                <a:solidFill>
-                  <a:srgbClr val="5B6B84"/>
-                </a:solidFill>
-                <a:effectLst/>
-                <a:uFillTx/>
-                <a:latin typeface="Calibri"/>
-                <a:ea typeface="Calibri"/>
-              </a:rPr>
-              <a:t>portée par une politique de </a:t>
-            </a:r>
-            <a:r>
-              <a:rPr lang="fr-FR" sz="1400" b="0" u="none" strike="noStrike">
-                <a:solidFill>
-                  <a:srgbClr val="5B6B84"/>
-                </a:solidFill>
-                <a:effectLst/>
-                <a:uFillTx/>
-                <a:latin typeface="Calibri"/>
-                <a:ea typeface="Calibri"/>
-              </a:rPr>
-              <a:t>gouvernance</a:t>
+              <a:t>portée par une politique de gouvernance</a:t>
             </a:r>
             <a:endParaRPr lang="fr-FR" sz="1400" b="0" u="none" strike="noStrike">
               <a:solidFill>
@@ -9879,7 +9915,7 @@
         <p:spPr>
           <a:xfrm>
             <a:off x="7560000" y="4617720"/>
-            <a:ext cx="4318200" cy="1551960"/>
+            <a:ext cx="4317840" cy="1551600"/>
           </a:xfrm>
           <a:prstGeom prst="roundRect">
             <a:avLst>
@@ -9934,7 +9970,7 @@
         <p:spPr>
           <a:xfrm>
             <a:off x="7740000" y="4754880"/>
-            <a:ext cx="3958200" cy="1277640"/>
+            <a:ext cx="3957840" cy="1277280"/>
           </a:xfrm>
           <a:prstGeom prst="rect">
             <a:avLst/>
@@ -9973,8 +10009,26 @@
                 <a:latin typeface="Calibri"/>
                 <a:ea typeface="Calibri"/>
               </a:rPr>
-              <a:t>Cadre partiellement défini </a:t>
-            </a:r>
+              <a:t>Cadre partiellement défini (rôles, outils) </a:t>
+            </a:r>
+            <a:endParaRPr lang="fr-FR" sz="1400" b="0" u="none" strike="noStrike">
+              <a:solidFill>
+                <a:srgbClr val="000000"/>
+              </a:solidFill>
+              <a:effectLst/>
+              <a:uFillTx/>
+              <a:latin typeface="Arial"/>
+            </a:endParaRPr>
+          </a:p>
+          <a:p>
+            <a:pPr defTabSz="914400">
+              <a:lnSpc>
+                <a:spcPct val="100000"/>
+              </a:lnSpc>
+              <a:tabLst>
+                <a:tab pos="0" algn="l"/>
+              </a:tabLst>
+            </a:pPr>
             <a:r>
               <a:rPr lang="fr-FR" sz="1400" b="0" i="1" u="none" strike="noStrike">
                 <a:solidFill>
@@ -9985,7 +10039,7 @@
                 <a:latin typeface="Calibri"/>
                 <a:ea typeface="Calibri"/>
               </a:rPr>
-              <a:t>(rôles, outils) </a:t>
+              <a:t>mais pas encore déployé : </a:t>
             </a:r>
             <a:endParaRPr lang="fr-FR" sz="1400" b="0" u="none" strike="noStrike">
               <a:solidFill>
@@ -10015,7 +10069,7 @@
                 <a:latin typeface="Calibri"/>
                 <a:ea typeface="Calibri"/>
               </a:rPr>
-              <a:t>mais pas encore déployé : </a:t>
+              <a:t>-  pas d’audit, </a:t>
             </a:r>
             <a:endParaRPr lang="fr-FR" sz="1400" b="0" u="none" strike="noStrike">
               <a:solidFill>
@@ -10045,7 +10099,7 @@
                 <a:latin typeface="Calibri"/>
                 <a:ea typeface="Calibri"/>
               </a:rPr>
-              <a:t>-  pas d’audit, </a:t>
+              <a:t>-  pas de monitoring, </a:t>
             </a:r>
             <a:endParaRPr lang="fr-FR" sz="1400" b="0" u="none" strike="noStrike">
               <a:solidFill>
@@ -10075,49 +10129,7 @@
                 <a:latin typeface="Calibri"/>
                 <a:ea typeface="Calibri"/>
               </a:rPr>
-              <a:t>-  pas de monitoring, </a:t>
-            </a:r>
-            <a:endParaRPr lang="fr-FR" sz="1400" b="0" u="none" strike="noStrike">
-              <a:solidFill>
-                <a:srgbClr val="000000"/>
-              </a:solidFill>
-              <a:effectLst/>
-              <a:uFillTx/>
-              <a:latin typeface="Arial"/>
-            </a:endParaRPr>
-          </a:p>
-          <a:p>
-            <a:pPr defTabSz="914400">
-              <a:lnSpc>
-                <a:spcPct val="100000"/>
-              </a:lnSpc>
-              <a:tabLst>
-                <a:tab pos="0" algn="l"/>
-              </a:tabLst>
-            </a:pPr>
-            <a:r>
-              <a:rPr lang="fr-FR" sz="1400" b="0" i="1" u="none" strike="noStrike">
-                <a:solidFill>
-                  <a:srgbClr val="1B2A4A"/>
-                </a:solidFill>
-                <a:effectLst/>
-                <a:uFillTx/>
-                <a:latin typeface="Calibri"/>
-                <a:ea typeface="Calibri"/>
-              </a:rPr>
-              <a:t>- pas de politique appliquée sur </a:t>
-            </a:r>
-            <a:r>
-              <a:rPr lang="fr-FR" sz="1400" b="0" i="1" u="none" strike="noStrike">
-                <a:solidFill>
-                  <a:srgbClr val="1B2A4A"/>
-                </a:solidFill>
-                <a:effectLst/>
-                <a:uFillTx/>
-                <a:latin typeface="Calibri"/>
-                <a:ea typeface="Calibri"/>
-              </a:rPr>
-              <a:t>le terrain.</a:t>
+              <a:t>- pas de politique appliquée sur le terrain.</a:t>
             </a:r>
             <a:endParaRPr lang="fr-FR" sz="1400" b="0" u="none" strike="noStrike">
               <a:solidFill>
@@ -10139,7 +10151,7 @@
         <p:spPr>
           <a:xfrm>
             <a:off x="548640" y="6473880"/>
-            <a:ext cx="8684280" cy="271800"/>
+            <a:ext cx="8683920" cy="271440"/>
           </a:xfrm>
           <a:prstGeom prst="rect">
             <a:avLst/>
@@ -10178,115 +10190,7 @@
                 <a:latin typeface="Calibri"/>
                 <a:ea typeface="Calibri"/>
               </a:rPr>
-              <a:t>Source : [D1] </a:t>
-            </a:r>
-            <a:r>
-              <a:rPr lang="fr-FR" sz="1100" b="0" i="1" u="none" strike="noStrike">
-                <a:solidFill>
-                  <a:srgbClr val="8493A8"/>
-                </a:solidFill>
-                <a:effectLst/>
-                <a:uFillTx/>
-                <a:latin typeface="Calibri"/>
-                <a:ea typeface="Calibri"/>
-              </a:rPr>
-              <a:t>(Data &amp; AI </a:t>
-            </a:r>
-            <a:r>
-              <a:rPr lang="fr-FR" sz="1100" b="0" i="1" u="none" strike="noStrike">
-                <a:solidFill>
-                  <a:srgbClr val="8493A8"/>
-                </a:solidFill>
-                <a:effectLst/>
-                <a:uFillTx/>
-                <a:latin typeface="Calibri"/>
-                <a:ea typeface="Calibri"/>
-              </a:rPr>
-              <a:t>Maturity </a:t>
-            </a:r>
-            <a:r>
-              <a:rPr lang="fr-FR" sz="1100" b="0" i="1" u="none" strike="noStrike">
-                <a:solidFill>
-                  <a:srgbClr val="8493A8"/>
-                </a:solidFill>
-                <a:effectLst/>
-                <a:uFillTx/>
-                <a:latin typeface="Calibri"/>
-                <a:ea typeface="Calibri"/>
-              </a:rPr>
-              <a:t>Assessment </a:t>
-            </a:r>
-            <a:r>
-              <a:rPr lang="fr-FR" sz="1100" b="0" i="1" u="none" strike="noStrike">
-                <a:solidFill>
-                  <a:srgbClr val="8493A8"/>
-                </a:solidFill>
-                <a:effectLst/>
-                <a:uFillTx/>
-                <a:latin typeface="Calibri"/>
-                <a:ea typeface="Calibri"/>
-              </a:rPr>
-              <a:t>Report) - </a:t>
-            </a:r>
-            <a:r>
-              <a:rPr lang="fr-FR" sz="1100" b="0" i="1" u="none" strike="noStrike">
-                <a:solidFill>
-                  <a:srgbClr val="8493A8"/>
-                </a:solidFill>
-                <a:effectLst/>
-                <a:uFillTx/>
-                <a:latin typeface="Calibri"/>
-                <a:ea typeface="Calibri"/>
-              </a:rPr>
-              <a:t>Méthodologie </a:t>
-            </a:r>
-            <a:r>
-              <a:rPr lang="fr-FR" sz="1100" b="0" i="1" u="none" strike="noStrike">
-                <a:solidFill>
-                  <a:srgbClr val="8493A8"/>
-                </a:solidFill>
-                <a:effectLst/>
-                <a:uFillTx/>
-                <a:latin typeface="Calibri"/>
-                <a:ea typeface="Calibri"/>
-              </a:rPr>
-              <a:t>[R1] </a:t>
-            </a:r>
-            <a:r>
-              <a:rPr lang="fr-FR" sz="1100" b="0" i="1" u="none" strike="noStrike">
-                <a:solidFill>
-                  <a:srgbClr val="8493A8"/>
-                </a:solidFill>
-                <a:effectLst/>
-                <a:uFillTx/>
-                <a:latin typeface="Calibri"/>
-                <a:ea typeface="Calibri"/>
-              </a:rPr>
-              <a:t>(Australian </a:t>
-            </a:r>
-            <a:r>
-              <a:rPr lang="fr-FR" sz="1100" b="0" i="1" u="none" strike="noStrike">
-                <a:solidFill>
-                  <a:srgbClr val="8493A8"/>
-                </a:solidFill>
-                <a:effectLst/>
-                <a:uFillTx/>
-                <a:latin typeface="Calibri"/>
-                <a:ea typeface="Calibri"/>
-              </a:rPr>
-              <a:t>Government </a:t>
-            </a:r>
-            <a:r>
-              <a:rPr lang="fr-FR" sz="1100" b="0" i="1" u="none" strike="noStrike">
-                <a:solidFill>
-                  <a:srgbClr val="8493A8"/>
-                </a:solidFill>
-                <a:effectLst/>
-                <a:uFillTx/>
-                <a:latin typeface="Calibri"/>
-                <a:ea typeface="Calibri"/>
-              </a:rPr>
-              <a:t>DMAT)</a:t>
+              <a:t>Source : [D1] (Data &amp; AI Maturity Assessment Report) - Méthodologie [R1] (Australian Government DMAT)</a:t>
             </a:r>
             <a:endParaRPr lang="fr-FR" sz="1100" b="0" u="none" strike="noStrike">
               <a:solidFill>
@@ -10308,7 +10212,7 @@
         <p:spPr>
           <a:xfrm>
             <a:off x="11003040" y="6473880"/>
-            <a:ext cx="820440" cy="271800"/>
+            <a:ext cx="820080" cy="271440"/>
           </a:xfrm>
           <a:prstGeom prst="rect">
             <a:avLst/>
@@ -10369,7 +10273,7 @@
         <p:spPr>
           <a:xfrm>
             <a:off x="7740000" y="2450520"/>
-            <a:ext cx="3958200" cy="546120"/>
+            <a:ext cx="3957840" cy="545760"/>
           </a:xfrm>
           <a:prstGeom prst="rect">
             <a:avLst/>
@@ -10430,7 +10334,7 @@
         <p:spPr>
           <a:xfrm>
             <a:off x="7739280" y="1800000"/>
-            <a:ext cx="1438920" cy="648000"/>
+            <a:ext cx="1438560" cy="647640"/>
           </a:xfrm>
           <a:prstGeom prst="rect">
             <a:avLst/>
@@ -10528,7 +10432,7 @@
         <p:spPr>
           <a:xfrm>
             <a:off x="548640" y="384120"/>
-            <a:ext cx="7312680" cy="290160"/>
+            <a:ext cx="7312320" cy="289800"/>
           </a:xfrm>
           <a:prstGeom prst="rect">
             <a:avLst/>
@@ -10589,7 +10493,7 @@
         <p:spPr>
           <a:xfrm>
             <a:off x="548640" y="658440"/>
-            <a:ext cx="9507240" cy="866160"/>
+            <a:ext cx="9506880" cy="865800"/>
           </a:xfrm>
           <a:prstGeom prst="rect">
             <a:avLst/>
@@ -10654,7 +10558,7 @@
         <p:spPr>
           <a:xfrm>
             <a:off x="11140200" y="365760"/>
-            <a:ext cx="655920" cy="655920"/>
+            <a:ext cx="655560" cy="655560"/>
           </a:xfrm>
           <a:prstGeom prst="rect">
             <a:avLst/>
@@ -10674,7 +10578,7 @@
         <p:spPr>
           <a:xfrm>
             <a:off x="591480" y="1689120"/>
-            <a:ext cx="5346720" cy="1369080"/>
+            <a:ext cx="5346360" cy="1368720"/>
           </a:xfrm>
           <a:prstGeom prst="roundRect">
             <a:avLst>
@@ -10729,7 +10633,7 @@
         <p:spPr>
           <a:xfrm>
             <a:off x="749880" y="1892880"/>
-            <a:ext cx="564480" cy="564480"/>
+            <a:ext cx="564120" cy="564120"/>
           </a:xfrm>
           <a:prstGeom prst="ellipse">
             <a:avLst/>
@@ -10772,7 +10676,7 @@
         <p:spPr>
           <a:xfrm>
             <a:off x="749880" y="1892880"/>
-            <a:ext cx="564480" cy="564480"/>
+            <a:ext cx="564120" cy="564120"/>
           </a:xfrm>
           <a:prstGeom prst="rect">
             <a:avLst/>
@@ -10833,7 +10737,7 @@
         <p:spPr>
           <a:xfrm>
             <a:off x="1463040" y="1837800"/>
-            <a:ext cx="4249440" cy="381600"/>
+            <a:ext cx="4249080" cy="381240"/>
           </a:xfrm>
           <a:prstGeom prst="rect">
             <a:avLst/>
@@ -10894,7 +10798,7 @@
         <p:spPr>
           <a:xfrm>
             <a:off x="1463040" y="2221920"/>
-            <a:ext cx="4249440" cy="774720"/>
+            <a:ext cx="4249080" cy="774360"/>
           </a:xfrm>
           <a:prstGeom prst="rect">
             <a:avLst/>
@@ -10955,7 +10859,7 @@
         <p:spPr>
           <a:xfrm>
             <a:off x="6217920" y="1691640"/>
-            <a:ext cx="5346720" cy="1369080"/>
+            <a:ext cx="5346360" cy="1368720"/>
           </a:xfrm>
           <a:prstGeom prst="roundRect">
             <a:avLst>
@@ -11010,7 +10914,7 @@
         <p:spPr>
           <a:xfrm>
             <a:off x="6419160" y="1892880"/>
-            <a:ext cx="564480" cy="564480"/>
+            <a:ext cx="564120" cy="564120"/>
           </a:xfrm>
           <a:prstGeom prst="ellipse">
             <a:avLst/>
@@ -11053,7 +10957,7 @@
         <p:spPr>
           <a:xfrm>
             <a:off x="6419160" y="1892880"/>
-            <a:ext cx="564480" cy="564480"/>
+            <a:ext cx="564120" cy="564120"/>
           </a:xfrm>
           <a:prstGeom prst="rect">
             <a:avLst/>
@@ -11092,7 +10996,19 @@
                 <a:latin typeface="Calibri"/>
                 <a:ea typeface="Calibri"/>
               </a:rPr>
-              <a:t>E2</a:t>
+              <a:t>E</a:t>
+            </a:r>
+            <a:r>
+              <a:rPr lang="fr-FR" sz="1400" b="1" u="none" strike="noStrike">
+                <a:solidFill>
+                  <a:srgbClr val="FFFFFF"/>
+                </a:solidFill>
+                <a:effectLst/>
+                <a:uFillTx/>
+                <a:latin typeface="Calibri"/>
+                <a:ea typeface="Calibri"/>
+              </a:rPr>
+              <a:t>2</a:t>
             </a:r>
             <a:endParaRPr lang="fr-FR" sz="1400" b="0" u="none" strike="noStrike">
               <a:solidFill>
@@ -11114,7 +11030,7 @@
         <p:spPr>
           <a:xfrm>
             <a:off x="7132320" y="1837800"/>
-            <a:ext cx="4249440" cy="381600"/>
+            <a:ext cx="4249080" cy="381240"/>
           </a:xfrm>
           <a:prstGeom prst="rect">
             <a:avLst/>
@@ -11175,7 +11091,7 @@
         <p:spPr>
           <a:xfrm>
             <a:off x="7132320" y="2221920"/>
-            <a:ext cx="4249440" cy="774720"/>
+            <a:ext cx="4249080" cy="774360"/>
           </a:xfrm>
           <a:prstGeom prst="rect">
             <a:avLst/>
@@ -11296,7 +11212,7 @@
         <p:spPr>
           <a:xfrm>
             <a:off x="548640" y="3319200"/>
-            <a:ext cx="5346720" cy="1369080"/>
+            <a:ext cx="5346360" cy="1368720"/>
           </a:xfrm>
           <a:prstGeom prst="roundRect">
             <a:avLst>
@@ -11351,7 +11267,7 @@
         <p:spPr>
           <a:xfrm>
             <a:off x="749880" y="3520440"/>
-            <a:ext cx="564480" cy="564480"/>
+            <a:ext cx="564120" cy="564120"/>
           </a:xfrm>
           <a:prstGeom prst="ellipse">
             <a:avLst/>
@@ -11394,7 +11310,7 @@
         <p:spPr>
           <a:xfrm>
             <a:off x="749880" y="3520440"/>
-            <a:ext cx="564480" cy="564480"/>
+            <a:ext cx="564120" cy="564120"/>
           </a:xfrm>
           <a:prstGeom prst="rect">
             <a:avLst/>
@@ -11433,7 +11349,19 @@
                 <a:latin typeface="Calibri"/>
                 <a:ea typeface="Calibri"/>
               </a:rPr>
-              <a:t>E3</a:t>
+              <a:t>E</a:t>
+            </a:r>
+            <a:r>
+              <a:rPr lang="fr-FR" sz="1400" b="1" u="none" strike="noStrike">
+                <a:solidFill>
+                  <a:srgbClr val="FFFFFF"/>
+                </a:solidFill>
+                <a:effectLst/>
+                <a:uFillTx/>
+                <a:latin typeface="Calibri"/>
+                <a:ea typeface="Calibri"/>
+              </a:rPr>
+              <a:t>3</a:t>
             </a:r>
             <a:endParaRPr lang="fr-FR" sz="1400" b="0" u="none" strike="noStrike">
               <a:solidFill>
@@ -11455,7 +11383,7 @@
         <p:spPr>
           <a:xfrm>
             <a:off x="1463040" y="3465720"/>
-            <a:ext cx="4249440" cy="381600"/>
+            <a:ext cx="4249080" cy="381240"/>
           </a:xfrm>
           <a:prstGeom prst="rect">
             <a:avLst/>
@@ -11516,7 +11444,7 @@
         <p:spPr>
           <a:xfrm>
             <a:off x="1463040" y="3849480"/>
-            <a:ext cx="4249440" cy="774720"/>
+            <a:ext cx="4249080" cy="774360"/>
           </a:xfrm>
           <a:prstGeom prst="rect">
             <a:avLst/>
@@ -11607,7 +11535,7 @@
         <p:spPr>
           <a:xfrm>
             <a:off x="6217920" y="3319200"/>
-            <a:ext cx="5346720" cy="1369080"/>
+            <a:ext cx="5346360" cy="1368720"/>
           </a:xfrm>
           <a:prstGeom prst="roundRect">
             <a:avLst>
@@ -11662,7 +11590,7 @@
         <p:spPr>
           <a:xfrm>
             <a:off x="6419160" y="3520440"/>
-            <a:ext cx="564480" cy="564480"/>
+            <a:ext cx="564120" cy="564120"/>
           </a:xfrm>
           <a:prstGeom prst="ellipse">
             <a:avLst/>
@@ -11705,7 +11633,7 @@
         <p:spPr>
           <a:xfrm>
             <a:off x="6419160" y="3520440"/>
-            <a:ext cx="564480" cy="564480"/>
+            <a:ext cx="564120" cy="564120"/>
           </a:xfrm>
           <a:prstGeom prst="rect">
             <a:avLst/>
@@ -11766,7 +11694,7 @@
         <p:spPr>
           <a:xfrm>
             <a:off x="7132320" y="3465720"/>
-            <a:ext cx="4249440" cy="381600"/>
+            <a:ext cx="4249080" cy="381240"/>
           </a:xfrm>
           <a:prstGeom prst="rect">
             <a:avLst/>
@@ -11827,7 +11755,7 @@
         <p:spPr>
           <a:xfrm>
             <a:off x="7132320" y="3849480"/>
-            <a:ext cx="4249440" cy="774720"/>
+            <a:ext cx="4249080" cy="774360"/>
           </a:xfrm>
           <a:prstGeom prst="rect">
             <a:avLst/>
@@ -11866,7 +11794,643 @@
                 <a:latin typeface="Calibri"/>
                 <a:ea typeface="Calibri"/>
               </a:rPr>
-              <a:t>Transparence, anonymisation, maîtrise de l’utilisateur</a:t>
+              <a:t>T</a:t>
+            </a:r>
+            <a:r>
+              <a:rPr lang="fr-FR" sz="1400" b="0" u="none" strike="noStrike">
+                <a:solidFill>
+                  <a:srgbClr val="5B6B84"/>
+                </a:solidFill>
+                <a:effectLst/>
+                <a:uFillTx/>
+                <a:latin typeface="Calibri"/>
+                <a:ea typeface="Calibri"/>
+              </a:rPr>
+              <a:t>r</a:t>
+            </a:r>
+            <a:r>
+              <a:rPr lang="fr-FR" sz="1400" b="0" u="none" strike="noStrike">
+                <a:solidFill>
+                  <a:srgbClr val="5B6B84"/>
+                </a:solidFill>
+                <a:effectLst/>
+                <a:uFillTx/>
+                <a:latin typeface="Calibri"/>
+                <a:ea typeface="Calibri"/>
+              </a:rPr>
+              <a:t>a</a:t>
+            </a:r>
+            <a:r>
+              <a:rPr lang="fr-FR" sz="1400" b="0" u="none" strike="noStrike">
+                <a:solidFill>
+                  <a:srgbClr val="5B6B84"/>
+                </a:solidFill>
+                <a:effectLst/>
+                <a:uFillTx/>
+                <a:latin typeface="Calibri"/>
+                <a:ea typeface="Calibri"/>
+              </a:rPr>
+              <a:t>n</a:t>
+            </a:r>
+            <a:r>
+              <a:rPr lang="fr-FR" sz="1400" b="0" u="none" strike="noStrike">
+                <a:solidFill>
+                  <a:srgbClr val="5B6B84"/>
+                </a:solidFill>
+                <a:effectLst/>
+                <a:uFillTx/>
+                <a:latin typeface="Calibri"/>
+                <a:ea typeface="Calibri"/>
+              </a:rPr>
+              <a:t>s</a:t>
+            </a:r>
+            <a:r>
+              <a:rPr lang="fr-FR" sz="1400" b="0" u="none" strike="noStrike">
+                <a:solidFill>
+                  <a:srgbClr val="5B6B84"/>
+                </a:solidFill>
+                <a:effectLst/>
+                <a:uFillTx/>
+                <a:latin typeface="Calibri"/>
+                <a:ea typeface="Calibri"/>
+              </a:rPr>
+              <a:t>p</a:t>
+            </a:r>
+            <a:r>
+              <a:rPr lang="fr-FR" sz="1400" b="0" u="none" strike="noStrike">
+                <a:solidFill>
+                  <a:srgbClr val="5B6B84"/>
+                </a:solidFill>
+                <a:effectLst/>
+                <a:uFillTx/>
+                <a:latin typeface="Calibri"/>
+                <a:ea typeface="Calibri"/>
+              </a:rPr>
+              <a:t>a</a:t>
+            </a:r>
+            <a:r>
+              <a:rPr lang="fr-FR" sz="1400" b="0" u="none" strike="noStrike">
+                <a:solidFill>
+                  <a:srgbClr val="5B6B84"/>
+                </a:solidFill>
+                <a:effectLst/>
+                <a:uFillTx/>
+                <a:latin typeface="Calibri"/>
+                <a:ea typeface="Calibri"/>
+              </a:rPr>
+              <a:t>r</a:t>
+            </a:r>
+            <a:r>
+              <a:rPr lang="fr-FR" sz="1400" b="0" u="none" strike="noStrike">
+                <a:solidFill>
+                  <a:srgbClr val="5B6B84"/>
+                </a:solidFill>
+                <a:effectLst/>
+                <a:uFillTx/>
+                <a:latin typeface="Calibri"/>
+                <a:ea typeface="Calibri"/>
+              </a:rPr>
+              <a:t>e</a:t>
+            </a:r>
+            <a:r>
+              <a:rPr lang="fr-FR" sz="1400" b="0" u="none" strike="noStrike">
+                <a:solidFill>
+                  <a:srgbClr val="5B6B84"/>
+                </a:solidFill>
+                <a:effectLst/>
+                <a:uFillTx/>
+                <a:latin typeface="Calibri"/>
+                <a:ea typeface="Calibri"/>
+              </a:rPr>
+              <a:t>n</a:t>
+            </a:r>
+            <a:r>
+              <a:rPr lang="fr-FR" sz="1400" b="0" u="none" strike="noStrike">
+                <a:solidFill>
+                  <a:srgbClr val="5B6B84"/>
+                </a:solidFill>
+                <a:effectLst/>
+                <a:uFillTx/>
+                <a:latin typeface="Calibri"/>
+                <a:ea typeface="Calibri"/>
+              </a:rPr>
+              <a:t>c</a:t>
+            </a:r>
+            <a:r>
+              <a:rPr lang="fr-FR" sz="1400" b="0" u="none" strike="noStrike">
+                <a:solidFill>
+                  <a:srgbClr val="5B6B84"/>
+                </a:solidFill>
+                <a:effectLst/>
+                <a:uFillTx/>
+                <a:latin typeface="Calibri"/>
+                <a:ea typeface="Calibri"/>
+              </a:rPr>
+              <a:t>e</a:t>
+            </a:r>
+            <a:r>
+              <a:rPr lang="fr-FR" sz="1400" b="0" u="none" strike="noStrike">
+                <a:solidFill>
+                  <a:srgbClr val="5B6B84"/>
+                </a:solidFill>
+                <a:effectLst/>
+                <a:uFillTx/>
+                <a:latin typeface="Calibri"/>
+                <a:ea typeface="Calibri"/>
+              </a:rPr>
+              <a:t>,</a:t>
+            </a:r>
+            <a:r>
+              <a:rPr lang="fr-FR" sz="1400" b="0" u="none" strike="noStrike">
+                <a:solidFill>
+                  <a:srgbClr val="5B6B84"/>
+                </a:solidFill>
+                <a:effectLst/>
+                <a:uFillTx/>
+                <a:latin typeface="Calibri"/>
+                <a:ea typeface="Calibri"/>
+              </a:rPr>
+              <a:t> </a:t>
+            </a:r>
+            <a:r>
+              <a:rPr lang="fr-FR" sz="1400" b="0" u="none" strike="noStrike">
+                <a:solidFill>
+                  <a:srgbClr val="5B6B84"/>
+                </a:solidFill>
+                <a:effectLst/>
+                <a:uFillTx/>
+                <a:latin typeface="Calibri"/>
+                <a:ea typeface="Calibri"/>
+              </a:rPr>
+              <a:t>a</a:t>
+            </a:r>
+            <a:r>
+              <a:rPr lang="fr-FR" sz="1400" b="0" u="none" strike="noStrike">
+                <a:solidFill>
+                  <a:srgbClr val="5B6B84"/>
+                </a:solidFill>
+                <a:effectLst/>
+                <a:uFillTx/>
+                <a:latin typeface="Calibri"/>
+                <a:ea typeface="Calibri"/>
+              </a:rPr>
+              <a:t>n</a:t>
+            </a:r>
+            <a:r>
+              <a:rPr lang="fr-FR" sz="1400" b="0" u="none" strike="noStrike">
+                <a:solidFill>
+                  <a:srgbClr val="5B6B84"/>
+                </a:solidFill>
+                <a:effectLst/>
+                <a:uFillTx/>
+                <a:latin typeface="Calibri"/>
+                <a:ea typeface="Calibri"/>
+              </a:rPr>
+              <a:t>o</a:t>
+            </a:r>
+            <a:r>
+              <a:rPr lang="fr-FR" sz="1400" b="0" u="none" strike="noStrike">
+                <a:solidFill>
+                  <a:srgbClr val="5B6B84"/>
+                </a:solidFill>
+                <a:effectLst/>
+                <a:uFillTx/>
+                <a:latin typeface="Calibri"/>
+                <a:ea typeface="Calibri"/>
+              </a:rPr>
+              <a:t>n</a:t>
+            </a:r>
+            <a:r>
+              <a:rPr lang="fr-FR" sz="1400" b="0" u="none" strike="noStrike">
+                <a:solidFill>
+                  <a:srgbClr val="5B6B84"/>
+                </a:solidFill>
+                <a:effectLst/>
+                <a:uFillTx/>
+                <a:latin typeface="Calibri"/>
+                <a:ea typeface="Calibri"/>
+              </a:rPr>
+              <a:t>y</a:t>
+            </a:r>
+            <a:r>
+              <a:rPr lang="fr-FR" sz="1400" b="0" u="none" strike="noStrike">
+                <a:solidFill>
+                  <a:srgbClr val="5B6B84"/>
+                </a:solidFill>
+                <a:effectLst/>
+                <a:uFillTx/>
+                <a:latin typeface="Calibri"/>
+                <a:ea typeface="Calibri"/>
+              </a:rPr>
+              <a:t>m</a:t>
+            </a:r>
+            <a:r>
+              <a:rPr lang="fr-FR" sz="1400" b="0" u="none" strike="noStrike">
+                <a:solidFill>
+                  <a:srgbClr val="5B6B84"/>
+                </a:solidFill>
+                <a:effectLst/>
+                <a:uFillTx/>
+                <a:latin typeface="Calibri"/>
+                <a:ea typeface="Calibri"/>
+              </a:rPr>
+              <a:t>i</a:t>
+            </a:r>
+            <a:r>
+              <a:rPr lang="fr-FR" sz="1400" b="0" u="none" strike="noStrike">
+                <a:solidFill>
+                  <a:srgbClr val="5B6B84"/>
+                </a:solidFill>
+                <a:effectLst/>
+                <a:uFillTx/>
+                <a:latin typeface="Calibri"/>
+                <a:ea typeface="Calibri"/>
+              </a:rPr>
+              <a:t>s</a:t>
+            </a:r>
+            <a:r>
+              <a:rPr lang="fr-FR" sz="1400" b="0" u="none" strike="noStrike">
+                <a:solidFill>
+                  <a:srgbClr val="5B6B84"/>
+                </a:solidFill>
+                <a:effectLst/>
+                <a:uFillTx/>
+                <a:latin typeface="Calibri"/>
+                <a:ea typeface="Calibri"/>
+              </a:rPr>
+              <a:t>a</a:t>
+            </a:r>
+            <a:r>
+              <a:rPr lang="fr-FR" sz="1400" b="0" u="none" strike="noStrike">
+                <a:solidFill>
+                  <a:srgbClr val="5B6B84"/>
+                </a:solidFill>
+                <a:effectLst/>
+                <a:uFillTx/>
+                <a:latin typeface="Calibri"/>
+                <a:ea typeface="Calibri"/>
+              </a:rPr>
+              <a:t>t</a:t>
+            </a:r>
+            <a:r>
+              <a:rPr lang="fr-FR" sz="1400" b="0" u="none" strike="noStrike">
+                <a:solidFill>
+                  <a:srgbClr val="5B6B84"/>
+                </a:solidFill>
+                <a:effectLst/>
+                <a:uFillTx/>
+                <a:latin typeface="Calibri"/>
+                <a:ea typeface="Calibri"/>
+              </a:rPr>
+              <a:t>i</a:t>
+            </a:r>
+            <a:r>
+              <a:rPr lang="fr-FR" sz="1400" b="0" u="none" strike="noStrike">
+                <a:solidFill>
+                  <a:srgbClr val="5B6B84"/>
+                </a:solidFill>
+                <a:effectLst/>
+                <a:uFillTx/>
+                <a:latin typeface="Calibri"/>
+                <a:ea typeface="Calibri"/>
+              </a:rPr>
+              <a:t>o</a:t>
+            </a:r>
+            <a:r>
+              <a:rPr lang="fr-FR" sz="1400" b="0" u="none" strike="noStrike">
+                <a:solidFill>
+                  <a:srgbClr val="5B6B84"/>
+                </a:solidFill>
+                <a:effectLst/>
+                <a:uFillTx/>
+                <a:latin typeface="Calibri"/>
+                <a:ea typeface="Calibri"/>
+              </a:rPr>
+              <a:t>n</a:t>
+            </a:r>
+            <a:r>
+              <a:rPr lang="fr-FR" sz="1400" b="0" u="none" strike="noStrike">
+                <a:solidFill>
+                  <a:srgbClr val="5B6B84"/>
+                </a:solidFill>
+                <a:effectLst/>
+                <a:uFillTx/>
+                <a:latin typeface="Calibri"/>
+                <a:ea typeface="Calibri"/>
+              </a:rPr>
+              <a:t>,</a:t>
+            </a:r>
+            <a:r>
+              <a:rPr lang="fr-FR" sz="1400" b="0" u="none" strike="noStrike">
+                <a:solidFill>
+                  <a:srgbClr val="5B6B84"/>
+                </a:solidFill>
+                <a:effectLst/>
+                <a:uFillTx/>
+                <a:latin typeface="Calibri"/>
+                <a:ea typeface="Calibri"/>
+              </a:rPr>
+              <a:t> </a:t>
+            </a:r>
+            <a:r>
+              <a:rPr lang="fr-FR" sz="1400" b="0" u="none" strike="noStrike">
+                <a:solidFill>
+                  <a:srgbClr val="5B6B84"/>
+                </a:solidFill>
+                <a:effectLst/>
+                <a:uFillTx/>
+                <a:latin typeface="Calibri"/>
+                <a:ea typeface="Calibri"/>
+              </a:rPr>
+              <a:t>m</a:t>
+            </a:r>
+            <a:r>
+              <a:rPr lang="fr-FR" sz="1400" b="0" u="none" strike="noStrike">
+                <a:solidFill>
+                  <a:srgbClr val="5B6B84"/>
+                </a:solidFill>
+                <a:effectLst/>
+                <a:uFillTx/>
+                <a:latin typeface="Calibri"/>
+                <a:ea typeface="Calibri"/>
+              </a:rPr>
+              <a:t>a</a:t>
+            </a:r>
+            <a:r>
+              <a:rPr lang="fr-FR" sz="1400" b="0" u="none" strike="noStrike">
+                <a:solidFill>
+                  <a:srgbClr val="5B6B84"/>
+                </a:solidFill>
+                <a:effectLst/>
+                <a:uFillTx/>
+                <a:latin typeface="Calibri"/>
+                <a:ea typeface="Calibri"/>
+              </a:rPr>
+              <a:t>î</a:t>
+            </a:r>
+            <a:r>
+              <a:rPr lang="fr-FR" sz="1400" b="0" u="none" strike="noStrike">
+                <a:solidFill>
+                  <a:srgbClr val="5B6B84"/>
+                </a:solidFill>
+                <a:effectLst/>
+                <a:uFillTx/>
+                <a:latin typeface="Calibri"/>
+                <a:ea typeface="Calibri"/>
+              </a:rPr>
+              <a:t>t</a:t>
+            </a:r>
+            <a:r>
+              <a:rPr lang="fr-FR" sz="1400" b="0" u="none" strike="noStrike">
+                <a:solidFill>
+                  <a:srgbClr val="5B6B84"/>
+                </a:solidFill>
+                <a:effectLst/>
+                <a:uFillTx/>
+                <a:latin typeface="Calibri"/>
+                <a:ea typeface="Calibri"/>
+              </a:rPr>
+              <a:t>r</a:t>
+            </a:r>
+            <a:r>
+              <a:rPr lang="fr-FR" sz="1400" b="0" u="none" strike="noStrike">
+                <a:solidFill>
+                  <a:srgbClr val="5B6B84"/>
+                </a:solidFill>
+                <a:effectLst/>
+                <a:uFillTx/>
+                <a:latin typeface="Calibri"/>
+                <a:ea typeface="Calibri"/>
+              </a:rPr>
+              <a:t>i</a:t>
+            </a:r>
+            <a:r>
+              <a:rPr lang="fr-FR" sz="1400" b="0" u="none" strike="noStrike">
+                <a:solidFill>
+                  <a:srgbClr val="5B6B84"/>
+                </a:solidFill>
+                <a:effectLst/>
+                <a:uFillTx/>
+                <a:latin typeface="Calibri"/>
+                <a:ea typeface="Calibri"/>
+              </a:rPr>
+              <a:t>s</a:t>
+            </a:r>
+            <a:r>
+              <a:rPr lang="fr-FR" sz="1400" b="0" u="none" strike="noStrike">
+                <a:solidFill>
+                  <a:srgbClr val="5B6B84"/>
+                </a:solidFill>
+                <a:effectLst/>
+                <a:uFillTx/>
+                <a:latin typeface="Calibri"/>
+                <a:ea typeface="Calibri"/>
+              </a:rPr>
+              <a:t>e</a:t>
+            </a:r>
+            <a:r>
+              <a:rPr lang="fr-FR" sz="1400" b="0" u="none" strike="noStrike">
+                <a:solidFill>
+                  <a:srgbClr val="5B6B84"/>
+                </a:solidFill>
+                <a:effectLst/>
+                <a:uFillTx/>
+                <a:latin typeface="Calibri"/>
+                <a:ea typeface="Calibri"/>
+              </a:rPr>
+              <a:t> </a:t>
+            </a:r>
+            <a:r>
+              <a:rPr lang="fr-FR" sz="1400" b="0" u="none" strike="noStrike">
+                <a:solidFill>
+                  <a:srgbClr val="5B6B84"/>
+                </a:solidFill>
+                <a:effectLst/>
+                <a:uFillTx/>
+                <a:latin typeface="Calibri"/>
+                <a:ea typeface="Calibri"/>
+              </a:rPr>
+              <a:t>d</a:t>
+            </a:r>
+            <a:r>
+              <a:rPr lang="fr-FR" sz="1400" b="0" u="none" strike="noStrike">
+                <a:solidFill>
+                  <a:srgbClr val="5B6B84"/>
+                </a:solidFill>
+                <a:effectLst/>
+                <a:uFillTx/>
+                <a:latin typeface="Calibri"/>
+                <a:ea typeface="Calibri"/>
+              </a:rPr>
+              <a:t>e</a:t>
+            </a:r>
+            <a:r>
+              <a:rPr lang="fr-FR" sz="1400" b="0" u="none" strike="noStrike">
+                <a:solidFill>
+                  <a:srgbClr val="5B6B84"/>
+                </a:solidFill>
+                <a:effectLst/>
+                <a:uFillTx/>
+                <a:latin typeface="Calibri"/>
+                <a:ea typeface="Calibri"/>
+              </a:rPr>
+              <a:t> </a:t>
+            </a:r>
+            <a:r>
+              <a:rPr lang="fr-FR" sz="1400" b="0" u="none" strike="noStrike">
+                <a:solidFill>
+                  <a:srgbClr val="5B6B84"/>
+                </a:solidFill>
+                <a:effectLst/>
+                <a:uFillTx/>
+                <a:latin typeface="Calibri"/>
+                <a:ea typeface="Calibri"/>
+              </a:rPr>
+              <a:t>l</a:t>
+            </a:r>
+            <a:r>
+              <a:rPr lang="fr-FR" sz="1400" b="0" u="none" strike="noStrike">
+                <a:solidFill>
+                  <a:srgbClr val="5B6B84"/>
+                </a:solidFill>
+                <a:effectLst/>
+                <a:uFillTx/>
+                <a:latin typeface="Calibri"/>
+                <a:ea typeface="Calibri"/>
+              </a:rPr>
+              <a:t>’</a:t>
+            </a:r>
+            <a:r>
+              <a:rPr lang="fr-FR" sz="1400" b="0" u="none" strike="noStrike">
+                <a:solidFill>
+                  <a:srgbClr val="5B6B84"/>
+                </a:solidFill>
+                <a:effectLst/>
+                <a:uFillTx/>
+                <a:latin typeface="Calibri"/>
+                <a:ea typeface="Calibri"/>
+              </a:rPr>
+              <a:t>u</a:t>
+            </a:r>
+            <a:r>
+              <a:rPr lang="fr-FR" sz="1400" b="0" u="none" strike="noStrike">
+                <a:solidFill>
+                  <a:srgbClr val="5B6B84"/>
+                </a:solidFill>
+                <a:effectLst/>
+                <a:uFillTx/>
+                <a:latin typeface="Calibri"/>
+                <a:ea typeface="Calibri"/>
+              </a:rPr>
+              <a:t>t</a:t>
+            </a:r>
+            <a:r>
+              <a:rPr lang="fr-FR" sz="1400" b="0" u="none" strike="noStrike">
+                <a:solidFill>
+                  <a:srgbClr val="5B6B84"/>
+                </a:solidFill>
+                <a:effectLst/>
+                <a:uFillTx/>
+                <a:latin typeface="Calibri"/>
+                <a:ea typeface="Calibri"/>
+              </a:rPr>
+              <a:t>i</a:t>
+            </a:r>
+            <a:r>
+              <a:rPr lang="fr-FR" sz="1400" b="0" u="none" strike="noStrike">
+                <a:solidFill>
+                  <a:srgbClr val="5B6B84"/>
+                </a:solidFill>
+                <a:effectLst/>
+                <a:uFillTx/>
+                <a:latin typeface="Calibri"/>
+                <a:ea typeface="Calibri"/>
+              </a:rPr>
+              <a:t>l</a:t>
+            </a:r>
+            <a:r>
+              <a:rPr lang="fr-FR" sz="1400" b="0" u="none" strike="noStrike">
+                <a:solidFill>
+                  <a:srgbClr val="5B6B84"/>
+                </a:solidFill>
+                <a:effectLst/>
+                <a:uFillTx/>
+                <a:latin typeface="Calibri"/>
+                <a:ea typeface="Calibri"/>
+              </a:rPr>
+              <a:t>i</a:t>
+            </a:r>
+            <a:r>
+              <a:rPr lang="fr-FR" sz="1400" b="0" u="none" strike="noStrike">
+                <a:solidFill>
+                  <a:srgbClr val="5B6B84"/>
+                </a:solidFill>
+                <a:effectLst/>
+                <a:uFillTx/>
+                <a:latin typeface="Calibri"/>
+                <a:ea typeface="Calibri"/>
+              </a:rPr>
+              <a:t>s</a:t>
+            </a:r>
+            <a:r>
+              <a:rPr lang="fr-FR" sz="1400" b="0" u="none" strike="noStrike">
+                <a:solidFill>
+                  <a:srgbClr val="5B6B84"/>
+                </a:solidFill>
+                <a:effectLst/>
+                <a:uFillTx/>
+                <a:latin typeface="Calibri"/>
+                <a:ea typeface="Calibri"/>
+              </a:rPr>
+              <a:t>a</a:t>
+            </a:r>
+            <a:r>
+              <a:rPr lang="fr-FR" sz="1400" b="0" u="none" strike="noStrike">
+                <a:solidFill>
+                  <a:srgbClr val="5B6B84"/>
+                </a:solidFill>
+                <a:effectLst/>
+                <a:uFillTx/>
+                <a:latin typeface="Calibri"/>
+                <a:ea typeface="Calibri"/>
+              </a:rPr>
+              <a:t>t</a:t>
+            </a:r>
+            <a:r>
+              <a:rPr lang="fr-FR" sz="1400" b="0" u="none" strike="noStrike">
+                <a:solidFill>
+                  <a:srgbClr val="5B6B84"/>
+                </a:solidFill>
+                <a:effectLst/>
+                <a:uFillTx/>
+                <a:latin typeface="Calibri"/>
+                <a:ea typeface="Calibri"/>
+              </a:rPr>
+              <a:t>e</a:t>
+            </a:r>
+            <a:r>
+              <a:rPr lang="fr-FR" sz="1400" b="0" u="none" strike="noStrike">
+                <a:solidFill>
+                  <a:srgbClr val="5B6B84"/>
+                </a:solidFill>
+                <a:effectLst/>
+                <a:uFillTx/>
+                <a:latin typeface="Calibri"/>
+                <a:ea typeface="Calibri"/>
+              </a:rPr>
+              <a:t>u</a:t>
+            </a:r>
+            <a:r>
+              <a:rPr lang="fr-FR" sz="1400" b="0" u="none" strike="noStrike">
+                <a:solidFill>
+                  <a:srgbClr val="5B6B84"/>
+                </a:solidFill>
+                <a:effectLst/>
+                <a:uFillTx/>
+                <a:latin typeface="Calibri"/>
+                <a:ea typeface="Calibri"/>
+              </a:rPr>
+              <a:t>r</a:t>
             </a:r>
             <a:endParaRPr lang="fr-FR" sz="1400" b="0" u="none" strike="noStrike">
               <a:solidFill>
@@ -11896,7 +12460,439 @@
                 <a:latin typeface="Calibri"/>
                 <a:ea typeface="Calibri"/>
               </a:rPr>
-              <a:t>Au-delà de la seule conformité légale</a:t>
+              <a:t>A</a:t>
+            </a:r>
+            <a:r>
+              <a:rPr lang="fr-FR" sz="1400" b="0" u="none" strike="noStrike">
+                <a:solidFill>
+                  <a:srgbClr val="5B6B84"/>
+                </a:solidFill>
+                <a:effectLst/>
+                <a:uFillTx/>
+                <a:latin typeface="Calibri"/>
+                <a:ea typeface="Calibri"/>
+              </a:rPr>
+              <a:t>u</a:t>
+            </a:r>
+            <a:r>
+              <a:rPr lang="fr-FR" sz="1400" b="0" u="none" strike="noStrike">
+                <a:solidFill>
+                  <a:srgbClr val="5B6B84"/>
+                </a:solidFill>
+                <a:effectLst/>
+                <a:uFillTx/>
+                <a:latin typeface="Calibri"/>
+                <a:ea typeface="Calibri"/>
+              </a:rPr>
+              <a:t>-</a:t>
+            </a:r>
+            <a:r>
+              <a:rPr lang="fr-FR" sz="1400" b="0" u="none" strike="noStrike">
+                <a:solidFill>
+                  <a:srgbClr val="5B6B84"/>
+                </a:solidFill>
+                <a:effectLst/>
+                <a:uFillTx/>
+                <a:latin typeface="Calibri"/>
+                <a:ea typeface="Calibri"/>
+              </a:rPr>
+              <a:t>d</a:t>
+            </a:r>
+            <a:r>
+              <a:rPr lang="fr-FR" sz="1400" b="0" u="none" strike="noStrike">
+                <a:solidFill>
+                  <a:srgbClr val="5B6B84"/>
+                </a:solidFill>
+                <a:effectLst/>
+                <a:uFillTx/>
+                <a:latin typeface="Calibri"/>
+                <a:ea typeface="Calibri"/>
+              </a:rPr>
+              <a:t>e</a:t>
+            </a:r>
+            <a:r>
+              <a:rPr lang="fr-FR" sz="1400" b="0" u="none" strike="noStrike">
+                <a:solidFill>
+                  <a:srgbClr val="5B6B84"/>
+                </a:solidFill>
+                <a:effectLst/>
+                <a:uFillTx/>
+                <a:latin typeface="Calibri"/>
+                <a:ea typeface="Calibri"/>
+              </a:rPr>
+              <a:t>l</a:t>
+            </a:r>
+            <a:r>
+              <a:rPr lang="fr-FR" sz="1400" b="0" u="none" strike="noStrike">
+                <a:solidFill>
+                  <a:srgbClr val="5B6B84"/>
+                </a:solidFill>
+                <a:effectLst/>
+                <a:uFillTx/>
+                <a:latin typeface="Calibri"/>
+                <a:ea typeface="Calibri"/>
+              </a:rPr>
+              <a:t>à</a:t>
+            </a:r>
+            <a:r>
+              <a:rPr lang="fr-FR" sz="1400" b="0" u="none" strike="noStrike">
+                <a:solidFill>
+                  <a:srgbClr val="5B6B84"/>
+                </a:solidFill>
+                <a:effectLst/>
+                <a:uFillTx/>
+                <a:latin typeface="Calibri"/>
+                <a:ea typeface="Calibri"/>
+              </a:rPr>
+              <a:t> </a:t>
+            </a:r>
+            <a:r>
+              <a:rPr lang="fr-FR" sz="1400" b="0" u="none" strike="noStrike">
+                <a:solidFill>
+                  <a:srgbClr val="5B6B84"/>
+                </a:solidFill>
+                <a:effectLst/>
+                <a:uFillTx/>
+                <a:latin typeface="Calibri"/>
+                <a:ea typeface="Calibri"/>
+              </a:rPr>
+              <a:t>d</a:t>
+            </a:r>
+            <a:r>
+              <a:rPr lang="fr-FR" sz="1400" b="0" u="none" strike="noStrike">
+                <a:solidFill>
+                  <a:srgbClr val="5B6B84"/>
+                </a:solidFill>
+                <a:effectLst/>
+                <a:uFillTx/>
+                <a:latin typeface="Calibri"/>
+                <a:ea typeface="Calibri"/>
+              </a:rPr>
+              <a:t>e</a:t>
+            </a:r>
+            <a:r>
+              <a:rPr lang="fr-FR" sz="1400" b="0" u="none" strike="noStrike">
+                <a:solidFill>
+                  <a:srgbClr val="5B6B84"/>
+                </a:solidFill>
+                <a:effectLst/>
+                <a:uFillTx/>
+                <a:latin typeface="Calibri"/>
+                <a:ea typeface="Calibri"/>
+              </a:rPr>
+              <a:t> </a:t>
+            </a:r>
+            <a:r>
+              <a:rPr lang="fr-FR" sz="1400" b="0" u="none" strike="noStrike">
+                <a:solidFill>
+                  <a:srgbClr val="5B6B84"/>
+                </a:solidFill>
+                <a:effectLst/>
+                <a:uFillTx/>
+                <a:latin typeface="Calibri"/>
+                <a:ea typeface="Calibri"/>
+              </a:rPr>
+              <a:t>l</a:t>
+            </a:r>
+            <a:r>
+              <a:rPr lang="fr-FR" sz="1400" b="0" u="none" strike="noStrike">
+                <a:solidFill>
+                  <a:srgbClr val="5B6B84"/>
+                </a:solidFill>
+                <a:effectLst/>
+                <a:uFillTx/>
+                <a:latin typeface="Calibri"/>
+                <a:ea typeface="Calibri"/>
+              </a:rPr>
+              <a:t>a</a:t>
+            </a:r>
+            <a:r>
+              <a:rPr lang="fr-FR" sz="1400" b="0" u="none" strike="noStrike">
+                <a:solidFill>
+                  <a:srgbClr val="5B6B84"/>
+                </a:solidFill>
+                <a:effectLst/>
+                <a:uFillTx/>
+                <a:latin typeface="Calibri"/>
+                <a:ea typeface="Calibri"/>
+              </a:rPr>
+              <a:t> </a:t>
+            </a:r>
+            <a:r>
+              <a:rPr lang="fr-FR" sz="1400" b="0" u="none" strike="noStrike">
+                <a:solidFill>
+                  <a:srgbClr val="5B6B84"/>
+                </a:solidFill>
+                <a:effectLst/>
+                <a:uFillTx/>
+                <a:latin typeface="Calibri"/>
+                <a:ea typeface="Calibri"/>
+              </a:rPr>
+              <a:t>s</a:t>
+            </a:r>
+            <a:r>
+              <a:rPr lang="fr-FR" sz="1400" b="0" u="none" strike="noStrike">
+                <a:solidFill>
+                  <a:srgbClr val="5B6B84"/>
+                </a:solidFill>
+                <a:effectLst/>
+                <a:uFillTx/>
+                <a:latin typeface="Calibri"/>
+                <a:ea typeface="Calibri"/>
+              </a:rPr>
+              <a:t>e</a:t>
+            </a:r>
+            <a:r>
+              <a:rPr lang="fr-FR" sz="1400" b="0" u="none" strike="noStrike">
+                <a:solidFill>
+                  <a:srgbClr val="5B6B84"/>
+                </a:solidFill>
+                <a:effectLst/>
+                <a:uFillTx/>
+                <a:latin typeface="Calibri"/>
+                <a:ea typeface="Calibri"/>
+              </a:rPr>
+              <a:t>u</a:t>
+            </a:r>
+            <a:r>
+              <a:rPr lang="fr-FR" sz="1400" b="0" u="none" strike="noStrike">
+                <a:solidFill>
+                  <a:srgbClr val="5B6B84"/>
+                </a:solidFill>
+                <a:effectLst/>
+                <a:uFillTx/>
+                <a:latin typeface="Calibri"/>
+                <a:ea typeface="Calibri"/>
+              </a:rPr>
+              <a:t>l</a:t>
+            </a:r>
+            <a:r>
+              <a:rPr lang="fr-FR" sz="1400" b="0" u="none" strike="noStrike">
+                <a:solidFill>
+                  <a:srgbClr val="5B6B84"/>
+                </a:solidFill>
+                <a:effectLst/>
+                <a:uFillTx/>
+                <a:latin typeface="Calibri"/>
+                <a:ea typeface="Calibri"/>
+              </a:rPr>
+              <a:t>e</a:t>
+            </a:r>
+            <a:r>
+              <a:rPr lang="fr-FR" sz="1400" b="0" u="none" strike="noStrike">
+                <a:solidFill>
+                  <a:srgbClr val="5B6B84"/>
+                </a:solidFill>
+                <a:effectLst/>
+                <a:uFillTx/>
+                <a:latin typeface="Calibri"/>
+                <a:ea typeface="Calibri"/>
+              </a:rPr>
+              <a:t> </a:t>
+            </a:r>
+            <a:r>
+              <a:rPr lang="fr-FR" sz="1400" b="0" u="none" strike="noStrike">
+                <a:solidFill>
+                  <a:srgbClr val="5B6B84"/>
+                </a:solidFill>
+                <a:effectLst/>
+                <a:uFillTx/>
+                <a:latin typeface="Calibri"/>
+                <a:ea typeface="Calibri"/>
+              </a:rPr>
+              <a:t>c</a:t>
+            </a:r>
+            <a:r>
+              <a:rPr lang="fr-FR" sz="1400" b="0" u="none" strike="noStrike">
+                <a:solidFill>
+                  <a:srgbClr val="5B6B84"/>
+                </a:solidFill>
+                <a:effectLst/>
+                <a:uFillTx/>
+                <a:latin typeface="Calibri"/>
+                <a:ea typeface="Calibri"/>
+              </a:rPr>
+              <a:t>o</a:t>
+            </a:r>
+            <a:r>
+              <a:rPr lang="fr-FR" sz="1400" b="0" u="none" strike="noStrike">
+                <a:solidFill>
+                  <a:srgbClr val="5B6B84"/>
+                </a:solidFill>
+                <a:effectLst/>
+                <a:uFillTx/>
+                <a:latin typeface="Calibri"/>
+                <a:ea typeface="Calibri"/>
+              </a:rPr>
+              <a:t>n</a:t>
+            </a:r>
+            <a:r>
+              <a:rPr lang="fr-FR" sz="1400" b="0" u="none" strike="noStrike">
+                <a:solidFill>
+                  <a:srgbClr val="5B6B84"/>
+                </a:solidFill>
+                <a:effectLst/>
+                <a:uFillTx/>
+                <a:latin typeface="Calibri"/>
+                <a:ea typeface="Calibri"/>
+              </a:rPr>
+              <a:t>f</a:t>
+            </a:r>
+            <a:r>
+              <a:rPr lang="fr-FR" sz="1400" b="0" u="none" strike="noStrike">
+                <a:solidFill>
+                  <a:srgbClr val="5B6B84"/>
+                </a:solidFill>
+                <a:effectLst/>
+                <a:uFillTx/>
+                <a:latin typeface="Calibri"/>
+                <a:ea typeface="Calibri"/>
+              </a:rPr>
+              <a:t>o</a:t>
+            </a:r>
+            <a:r>
+              <a:rPr lang="fr-FR" sz="1400" b="0" u="none" strike="noStrike">
+                <a:solidFill>
+                  <a:srgbClr val="5B6B84"/>
+                </a:solidFill>
+                <a:effectLst/>
+                <a:uFillTx/>
+                <a:latin typeface="Calibri"/>
+                <a:ea typeface="Calibri"/>
+              </a:rPr>
+              <a:t>r</a:t>
+            </a:r>
+            <a:r>
+              <a:rPr lang="fr-FR" sz="1400" b="0" u="none" strike="noStrike">
+                <a:solidFill>
+                  <a:srgbClr val="5B6B84"/>
+                </a:solidFill>
+                <a:effectLst/>
+                <a:uFillTx/>
+                <a:latin typeface="Calibri"/>
+                <a:ea typeface="Calibri"/>
+              </a:rPr>
+              <a:t>m</a:t>
+            </a:r>
+            <a:r>
+              <a:rPr lang="fr-FR" sz="1400" b="0" u="none" strike="noStrike">
+                <a:solidFill>
+                  <a:srgbClr val="5B6B84"/>
+                </a:solidFill>
+                <a:effectLst/>
+                <a:uFillTx/>
+                <a:latin typeface="Calibri"/>
+                <a:ea typeface="Calibri"/>
+              </a:rPr>
+              <a:t>i</a:t>
+            </a:r>
+            <a:r>
+              <a:rPr lang="fr-FR" sz="1400" b="0" u="none" strike="noStrike">
+                <a:solidFill>
+                  <a:srgbClr val="5B6B84"/>
+                </a:solidFill>
+                <a:effectLst/>
+                <a:uFillTx/>
+                <a:latin typeface="Calibri"/>
+                <a:ea typeface="Calibri"/>
+              </a:rPr>
+              <a:t>t</a:t>
+            </a:r>
+            <a:r>
+              <a:rPr lang="fr-FR" sz="1400" b="0" u="none" strike="noStrike">
+                <a:solidFill>
+                  <a:srgbClr val="5B6B84"/>
+                </a:solidFill>
+                <a:effectLst/>
+                <a:uFillTx/>
+                <a:latin typeface="Calibri"/>
+                <a:ea typeface="Calibri"/>
+              </a:rPr>
+              <a:t>é</a:t>
+            </a:r>
+            <a:r>
+              <a:rPr lang="fr-FR" sz="1400" b="0" u="none" strike="noStrike">
+                <a:solidFill>
+                  <a:srgbClr val="5B6B84"/>
+                </a:solidFill>
+                <a:effectLst/>
+                <a:uFillTx/>
+                <a:latin typeface="Calibri"/>
+                <a:ea typeface="Calibri"/>
+              </a:rPr>
+              <a:t> </a:t>
+            </a:r>
+            <a:r>
+              <a:rPr lang="fr-FR" sz="1400" b="0" u="none" strike="noStrike">
+                <a:solidFill>
+                  <a:srgbClr val="5B6B84"/>
+                </a:solidFill>
+                <a:effectLst/>
+                <a:uFillTx/>
+                <a:latin typeface="Calibri"/>
+                <a:ea typeface="Calibri"/>
+              </a:rPr>
+              <a:t>l</a:t>
+            </a:r>
+            <a:r>
+              <a:rPr lang="fr-FR" sz="1400" b="0" u="none" strike="noStrike">
+                <a:solidFill>
+                  <a:srgbClr val="5B6B84"/>
+                </a:solidFill>
+                <a:effectLst/>
+                <a:uFillTx/>
+                <a:latin typeface="Calibri"/>
+                <a:ea typeface="Calibri"/>
+              </a:rPr>
+              <a:t>é</a:t>
+            </a:r>
+            <a:r>
+              <a:rPr lang="fr-FR" sz="1400" b="0" u="none" strike="noStrike">
+                <a:solidFill>
+                  <a:srgbClr val="5B6B84"/>
+                </a:solidFill>
+                <a:effectLst/>
+                <a:uFillTx/>
+                <a:latin typeface="Calibri"/>
+                <a:ea typeface="Calibri"/>
+              </a:rPr>
+              <a:t>g</a:t>
+            </a:r>
+            <a:r>
+              <a:rPr lang="fr-FR" sz="1400" b="0" u="none" strike="noStrike">
+                <a:solidFill>
+                  <a:srgbClr val="5B6B84"/>
+                </a:solidFill>
+                <a:effectLst/>
+                <a:uFillTx/>
+                <a:latin typeface="Calibri"/>
+                <a:ea typeface="Calibri"/>
+              </a:rPr>
+              <a:t>a</a:t>
+            </a:r>
+            <a:r>
+              <a:rPr lang="fr-FR" sz="1400" b="0" u="none" strike="noStrike">
+                <a:solidFill>
+                  <a:srgbClr val="5B6B84"/>
+                </a:solidFill>
+                <a:effectLst/>
+                <a:uFillTx/>
+                <a:latin typeface="Calibri"/>
+                <a:ea typeface="Calibri"/>
+              </a:rPr>
+              <a:t>l</a:t>
+            </a:r>
+            <a:r>
+              <a:rPr lang="fr-FR" sz="1400" b="0" u="none" strike="noStrike">
+                <a:solidFill>
+                  <a:srgbClr val="5B6B84"/>
+                </a:solidFill>
+                <a:effectLst/>
+                <a:uFillTx/>
+                <a:latin typeface="Calibri"/>
+                <a:ea typeface="Calibri"/>
+              </a:rPr>
+              <a:t>e</a:t>
             </a:r>
             <a:endParaRPr lang="fr-FR" sz="1400" b="0" u="none" strike="noStrike">
               <a:solidFill>
@@ -11918,7 +12914,7 @@
         <p:spPr>
           <a:xfrm>
             <a:off x="548640" y="4946760"/>
-            <a:ext cx="5346720" cy="1369080"/>
+            <a:ext cx="5346360" cy="1368720"/>
           </a:xfrm>
           <a:prstGeom prst="roundRect">
             <a:avLst>
@@ -11973,7 +12969,7 @@
         <p:spPr>
           <a:xfrm>
             <a:off x="749880" y="5148000"/>
-            <a:ext cx="564480" cy="564480"/>
+            <a:ext cx="564120" cy="564120"/>
           </a:xfrm>
           <a:prstGeom prst="ellipse">
             <a:avLst/>
@@ -12016,7 +13012,7 @@
         <p:spPr>
           <a:xfrm>
             <a:off x="749880" y="5148000"/>
-            <a:ext cx="564480" cy="564480"/>
+            <a:ext cx="564120" cy="564120"/>
           </a:xfrm>
           <a:prstGeom prst="rect">
             <a:avLst/>
@@ -12077,7 +13073,7 @@
         <p:spPr>
           <a:xfrm>
             <a:off x="1463040" y="5093280"/>
-            <a:ext cx="4249440" cy="381600"/>
+            <a:ext cx="4249080" cy="381240"/>
           </a:xfrm>
           <a:prstGeom prst="rect">
             <a:avLst/>
@@ -12138,7 +13134,7 @@
         <p:spPr>
           <a:xfrm>
             <a:off x="1463040" y="5477400"/>
-            <a:ext cx="4249440" cy="774720"/>
+            <a:ext cx="4249080" cy="774360"/>
           </a:xfrm>
           <a:prstGeom prst="rect">
             <a:avLst/>
@@ -12199,7 +13195,7 @@
         <p:spPr>
           <a:xfrm>
             <a:off x="6217920" y="4946760"/>
-            <a:ext cx="5346720" cy="1369080"/>
+            <a:ext cx="5346360" cy="1368720"/>
           </a:xfrm>
           <a:prstGeom prst="roundRect">
             <a:avLst>
@@ -12254,7 +13250,7 @@
         <p:spPr>
           <a:xfrm>
             <a:off x="6419160" y="5148000"/>
-            <a:ext cx="564480" cy="564480"/>
+            <a:ext cx="564120" cy="564120"/>
           </a:xfrm>
           <a:prstGeom prst="ellipse">
             <a:avLst/>
@@ -12297,7 +13293,7 @@
         <p:spPr>
           <a:xfrm>
             <a:off x="6419160" y="5148000"/>
-            <a:ext cx="564480" cy="564480"/>
+            <a:ext cx="564120" cy="564120"/>
           </a:xfrm>
           <a:prstGeom prst="rect">
             <a:avLst/>
@@ -12358,7 +13354,7 @@
         <p:spPr>
           <a:xfrm>
             <a:off x="7132320" y="5093280"/>
-            <a:ext cx="4249440" cy="381600"/>
+            <a:ext cx="4249080" cy="381240"/>
           </a:xfrm>
           <a:prstGeom prst="rect">
             <a:avLst/>
@@ -12431,7 +13427,7 @@
         <p:spPr>
           <a:xfrm>
             <a:off x="7132320" y="5477400"/>
-            <a:ext cx="4249440" cy="774720"/>
+            <a:ext cx="4249080" cy="774360"/>
           </a:xfrm>
           <a:prstGeom prst="rect">
             <a:avLst/>
@@ -12522,7 +13518,7 @@
         <p:spPr>
           <a:xfrm>
             <a:off x="548640" y="6473880"/>
-            <a:ext cx="8684280" cy="271800"/>
+            <a:ext cx="8683920" cy="271440"/>
           </a:xfrm>
           <a:prstGeom prst="rect">
             <a:avLst/>
@@ -12583,7 +13579,7 @@
         <p:spPr>
           <a:xfrm>
             <a:off x="11003040" y="6473880"/>
-            <a:ext cx="820440" cy="271800"/>
+            <a:ext cx="820080" cy="271440"/>
           </a:xfrm>
           <a:prstGeom prst="rect">
             <a:avLst/>
@@ -12681,7 +13677,7 @@
         <p:spPr>
           <a:xfrm>
             <a:off x="548640" y="384120"/>
-            <a:ext cx="7312680" cy="290160"/>
+            <a:ext cx="7312320" cy="289800"/>
           </a:xfrm>
           <a:prstGeom prst="rect">
             <a:avLst/>
@@ -12742,7 +13738,7 @@
         <p:spPr>
           <a:xfrm>
             <a:off x="548640" y="658440"/>
-            <a:ext cx="9690120" cy="866160"/>
+            <a:ext cx="9689760" cy="865800"/>
           </a:xfrm>
           <a:prstGeom prst="rect">
             <a:avLst/>
@@ -12807,7 +13803,7 @@
         <p:spPr>
           <a:xfrm>
             <a:off x="11140200" y="365760"/>
-            <a:ext cx="655920" cy="655920"/>
+            <a:ext cx="655560" cy="655560"/>
           </a:xfrm>
           <a:prstGeom prst="rect">
             <a:avLst/>
@@ -12827,7 +13823,7 @@
         <p:spPr>
           <a:xfrm>
             <a:off x="548640" y="1645920"/>
-            <a:ext cx="5346720" cy="2146320"/>
+            <a:ext cx="5346360" cy="2145960"/>
           </a:xfrm>
           <a:prstGeom prst="roundRect">
             <a:avLst>
@@ -12882,7 +13878,7 @@
         <p:spPr>
           <a:xfrm>
             <a:off x="720000" y="1810440"/>
-            <a:ext cx="4757040" cy="326520"/>
+            <a:ext cx="4756680" cy="326160"/>
           </a:xfrm>
           <a:prstGeom prst="rect">
             <a:avLst/>
@@ -12943,7 +13939,7 @@
         <p:spPr>
           <a:xfrm>
             <a:off x="858960" y="2248920"/>
-            <a:ext cx="381600" cy="381600"/>
+            <a:ext cx="381240" cy="381240"/>
           </a:xfrm>
           <a:prstGeom prst="ellipse">
             <a:avLst/>
@@ -12986,7 +13982,7 @@
         <p:spPr>
           <a:xfrm>
             <a:off x="858960" y="2248920"/>
-            <a:ext cx="381600" cy="381600"/>
+            <a:ext cx="381240" cy="381240"/>
           </a:xfrm>
           <a:prstGeom prst="rect">
             <a:avLst/>
@@ -13047,7 +14043,7 @@
         <p:spPr>
           <a:xfrm>
             <a:off x="1361880" y="2340000"/>
-            <a:ext cx="4432320" cy="410040"/>
+            <a:ext cx="4431960" cy="409680"/>
           </a:xfrm>
           <a:prstGeom prst="rect">
             <a:avLst/>
@@ -13138,7 +14134,7 @@
         <p:spPr>
           <a:xfrm>
             <a:off x="858960" y="2923920"/>
-            <a:ext cx="381600" cy="381600"/>
+            <a:ext cx="381240" cy="381240"/>
           </a:xfrm>
           <a:prstGeom prst="ellipse">
             <a:avLst/>
@@ -13181,7 +14177,7 @@
         <p:spPr>
           <a:xfrm>
             <a:off x="858960" y="2923920"/>
-            <a:ext cx="381600" cy="381600"/>
+            <a:ext cx="381240" cy="381240"/>
           </a:xfrm>
           <a:prstGeom prst="rect">
             <a:avLst/>
@@ -13242,7 +14238,7 @@
         <p:spPr>
           <a:xfrm>
             <a:off x="1361880" y="3004200"/>
-            <a:ext cx="4252320" cy="564480"/>
+            <a:ext cx="4251960" cy="564120"/>
           </a:xfrm>
           <a:prstGeom prst="rect">
             <a:avLst/>
@@ -13363,7 +14359,7 @@
         <p:spPr>
           <a:xfrm>
             <a:off x="6247800" y="1652040"/>
-            <a:ext cx="5346720" cy="2146320"/>
+            <a:ext cx="5346360" cy="2145960"/>
           </a:xfrm>
           <a:prstGeom prst="roundRect">
             <a:avLst>
@@ -13418,7 +14414,7 @@
         <p:spPr>
           <a:xfrm>
             <a:off x="6480000" y="1810440"/>
-            <a:ext cx="4810320" cy="326520"/>
+            <a:ext cx="4809960" cy="326160"/>
           </a:xfrm>
           <a:prstGeom prst="rect">
             <a:avLst/>
@@ -13479,7 +14475,7 @@
         <p:spPr>
           <a:xfrm>
             <a:off x="6564240" y="2212920"/>
-            <a:ext cx="381600" cy="381600"/>
+            <a:ext cx="381240" cy="381240"/>
           </a:xfrm>
           <a:prstGeom prst="ellipse">
             <a:avLst/>
@@ -13522,7 +14518,7 @@
         <p:spPr>
           <a:xfrm>
             <a:off x="6564240" y="2212920"/>
-            <a:ext cx="381600" cy="381600"/>
+            <a:ext cx="381240" cy="381240"/>
           </a:xfrm>
           <a:prstGeom prst="rect">
             <a:avLst/>
@@ -13583,7 +14579,7 @@
         <p:spPr>
           <a:xfrm>
             <a:off x="7020000" y="2304000"/>
-            <a:ext cx="4295160" cy="332640"/>
+            <a:ext cx="4294800" cy="332280"/>
           </a:xfrm>
           <a:prstGeom prst="rect">
             <a:avLst/>
@@ -13674,7 +14670,7 @@
         <p:spPr>
           <a:xfrm>
             <a:off x="6564240" y="2707920"/>
-            <a:ext cx="381600" cy="381600"/>
+            <a:ext cx="381240" cy="381240"/>
           </a:xfrm>
           <a:prstGeom prst="ellipse">
             <a:avLst/>
@@ -13717,7 +14713,7 @@
         <p:spPr>
           <a:xfrm>
             <a:off x="6564240" y="2707920"/>
-            <a:ext cx="381600" cy="381600"/>
+            <a:ext cx="381240" cy="381240"/>
           </a:xfrm>
           <a:prstGeom prst="rect">
             <a:avLst/>
@@ -13778,7 +14774,7 @@
         <p:spPr>
           <a:xfrm>
             <a:off x="7043040" y="2808000"/>
-            <a:ext cx="4295160" cy="564480"/>
+            <a:ext cx="4294800" cy="564120"/>
           </a:xfrm>
           <a:prstGeom prst="rect">
             <a:avLst/>
@@ -13869,7 +14865,7 @@
         <p:spPr>
           <a:xfrm>
             <a:off x="6564240" y="3204000"/>
-            <a:ext cx="381600" cy="381600"/>
+            <a:ext cx="381240" cy="381240"/>
           </a:xfrm>
           <a:prstGeom prst="ellipse">
             <a:avLst/>
@@ -13912,7 +14908,7 @@
         <p:spPr>
           <a:xfrm>
             <a:off x="6564240" y="3204000"/>
-            <a:ext cx="381600" cy="381600"/>
+            <a:ext cx="381240" cy="381240"/>
           </a:xfrm>
           <a:prstGeom prst="rect">
             <a:avLst/>
@@ -13973,7 +14969,7 @@
         <p:spPr>
           <a:xfrm>
             <a:off x="7020000" y="3319200"/>
-            <a:ext cx="4295160" cy="459000"/>
+            <a:ext cx="4294800" cy="458640"/>
           </a:xfrm>
           <a:prstGeom prst="rect">
             <a:avLst/>
@@ -14064,7 +15060,7 @@
         <p:spPr>
           <a:xfrm>
             <a:off x="548640" y="4023360"/>
-            <a:ext cx="5346720" cy="2146320"/>
+            <a:ext cx="5346360" cy="2145960"/>
           </a:xfrm>
           <a:prstGeom prst="roundRect">
             <a:avLst>
@@ -14119,7 +15115,7 @@
         <p:spPr>
           <a:xfrm>
             <a:off x="720000" y="4187880"/>
-            <a:ext cx="4901040" cy="326520"/>
+            <a:ext cx="4900680" cy="326160"/>
           </a:xfrm>
           <a:prstGeom prst="rect">
             <a:avLst/>
@@ -14180,7 +15176,7 @@
         <p:spPr>
           <a:xfrm>
             <a:off x="822960" y="4590360"/>
-            <a:ext cx="381600" cy="381600"/>
+            <a:ext cx="381240" cy="381240"/>
           </a:xfrm>
           <a:prstGeom prst="ellipse">
             <a:avLst/>
@@ -14223,7 +15219,7 @@
         <p:spPr>
           <a:xfrm>
             <a:off x="822960" y="4590360"/>
-            <a:ext cx="381600" cy="381600"/>
+            <a:ext cx="381240" cy="381240"/>
           </a:xfrm>
           <a:prstGeom prst="rect">
             <a:avLst/>
@@ -14284,7 +15280,7 @@
         <p:spPr>
           <a:xfrm>
             <a:off x="1325880" y="4671000"/>
-            <a:ext cx="4295160" cy="564480"/>
+            <a:ext cx="4294800" cy="564120"/>
           </a:xfrm>
           <a:prstGeom prst="rect">
             <a:avLst/>
@@ -14375,7 +15371,7 @@
         <p:spPr>
           <a:xfrm>
             <a:off x="822960" y="5301360"/>
-            <a:ext cx="381600" cy="381600"/>
+            <a:ext cx="381240" cy="381240"/>
           </a:xfrm>
           <a:prstGeom prst="ellipse">
             <a:avLst/>
@@ -14418,7 +15414,7 @@
         <p:spPr>
           <a:xfrm>
             <a:off x="822960" y="5301360"/>
-            <a:ext cx="381600" cy="381600"/>
+            <a:ext cx="381240" cy="381240"/>
           </a:xfrm>
           <a:prstGeom prst="rect">
             <a:avLst/>
@@ -14479,7 +15475,7 @@
         <p:spPr>
           <a:xfrm>
             <a:off x="1325880" y="5381640"/>
-            <a:ext cx="4295160" cy="564480"/>
+            <a:ext cx="4294800" cy="564120"/>
           </a:xfrm>
           <a:prstGeom prst="rect">
             <a:avLst/>
@@ -14570,7 +15566,7 @@
         <p:spPr>
           <a:xfrm>
             <a:off x="6217920" y="4023360"/>
-            <a:ext cx="5346720" cy="2146320"/>
+            <a:ext cx="5346360" cy="2145960"/>
           </a:xfrm>
           <a:prstGeom prst="roundRect">
             <a:avLst>
@@ -14625,7 +15621,7 @@
         <p:spPr>
           <a:xfrm>
             <a:off x="6480000" y="4187880"/>
-            <a:ext cx="4810320" cy="326520"/>
+            <a:ext cx="4809960" cy="326160"/>
           </a:xfrm>
           <a:prstGeom prst="rect">
             <a:avLst/>
@@ -14686,7 +15682,7 @@
         <p:spPr>
           <a:xfrm>
             <a:off x="6528240" y="4554360"/>
-            <a:ext cx="381600" cy="381600"/>
+            <a:ext cx="381240" cy="381240"/>
           </a:xfrm>
           <a:prstGeom prst="ellipse">
             <a:avLst/>
@@ -14729,7 +15725,7 @@
         <p:spPr>
           <a:xfrm>
             <a:off x="6528240" y="4554360"/>
-            <a:ext cx="381600" cy="381600"/>
+            <a:ext cx="381240" cy="381240"/>
           </a:xfrm>
           <a:prstGeom prst="rect">
             <a:avLst/>
@@ -14790,7 +15786,7 @@
         <p:spPr>
           <a:xfrm>
             <a:off x="6995160" y="4653720"/>
-            <a:ext cx="4295160" cy="564480"/>
+            <a:ext cx="4294800" cy="564120"/>
           </a:xfrm>
           <a:prstGeom prst="rect">
             <a:avLst/>
@@ -14881,7 +15877,7 @@
         <p:spPr>
           <a:xfrm>
             <a:off x="6528240" y="5229360"/>
-            <a:ext cx="381600" cy="381600"/>
+            <a:ext cx="381240" cy="381240"/>
           </a:xfrm>
           <a:prstGeom prst="ellipse">
             <a:avLst/>
@@ -14924,7 +15920,7 @@
         <p:spPr>
           <a:xfrm>
             <a:off x="6528240" y="5229360"/>
-            <a:ext cx="381600" cy="381600"/>
+            <a:ext cx="381240" cy="381240"/>
           </a:xfrm>
           <a:prstGeom prst="rect">
             <a:avLst/>
@@ -14985,7 +15981,7 @@
         <p:spPr>
           <a:xfrm>
             <a:off x="6995160" y="5309640"/>
-            <a:ext cx="4295160" cy="564480"/>
+            <a:ext cx="4294800" cy="564120"/>
           </a:xfrm>
           <a:prstGeom prst="rect">
             <a:avLst/>
@@ -15076,7 +16072,7 @@
         <p:spPr>
           <a:xfrm>
             <a:off x="548640" y="6473880"/>
-            <a:ext cx="8684280" cy="271800"/>
+            <a:ext cx="8683920" cy="271440"/>
           </a:xfrm>
           <a:prstGeom prst="rect">
             <a:avLst/>
@@ -15137,7 +16133,7 @@
         <p:spPr>
           <a:xfrm>
             <a:off x="11003040" y="6473880"/>
-            <a:ext cx="820440" cy="271800"/>
+            <a:ext cx="820080" cy="271440"/>
           </a:xfrm>
           <a:prstGeom prst="rect">
             <a:avLst/>
@@ -15235,7 +16231,7 @@
         <p:spPr>
           <a:xfrm>
             <a:off x="548640" y="384120"/>
-            <a:ext cx="7312680" cy="290160"/>
+            <a:ext cx="7312320" cy="289800"/>
           </a:xfrm>
           <a:prstGeom prst="rect">
             <a:avLst/>
@@ -15296,7 +16292,7 @@
         <p:spPr>
           <a:xfrm>
             <a:off x="548640" y="658440"/>
-            <a:ext cx="9507240" cy="866160"/>
+            <a:ext cx="9506880" cy="865800"/>
           </a:xfrm>
           <a:prstGeom prst="rect">
             <a:avLst/>
@@ -15373,7 +16369,7 @@
         <p:spPr>
           <a:xfrm>
             <a:off x="11140200" y="365760"/>
-            <a:ext cx="655920" cy="655920"/>
+            <a:ext cx="655560" cy="655560"/>
           </a:xfrm>
           <a:prstGeom prst="rect">
             <a:avLst/>
@@ -15393,7 +16389,7 @@
         <p:spPr>
           <a:xfrm>
             <a:off x="548640" y="1260000"/>
-            <a:ext cx="3409560" cy="5001120"/>
+            <a:ext cx="3409200" cy="5000760"/>
           </a:xfrm>
           <a:prstGeom prst="roundRect">
             <a:avLst>
@@ -15448,7 +16444,7 @@
         <p:spPr>
           <a:xfrm>
             <a:off x="720000" y="1526400"/>
-            <a:ext cx="2955240" cy="290160"/>
+            <a:ext cx="2954880" cy="289800"/>
           </a:xfrm>
           <a:prstGeom prst="rect">
             <a:avLst/>
@@ -15511,19 +16507,7 @@
                 <a:latin typeface="Calibri"/>
                 <a:ea typeface="Calibri"/>
               </a:rPr>
-              <a:t> + adaptation </a:t>
-            </a:r>
-            <a:r>
-              <a:rPr lang="fr-FR" sz="1300" b="1" u="none" strike="noStrike">
-                <a:solidFill>
-                  <a:srgbClr val="1C8C68"/>
-                </a:solidFill>
-                <a:effectLst/>
-                <a:uFillTx/>
-                <a:latin typeface="Calibri"/>
-                <a:ea typeface="Calibri"/>
-              </a:rPr>
-              <a:t>Spotify</a:t>
+              <a:t> + adaptation Spotify</a:t>
             </a:r>
             <a:endParaRPr lang="fr-FR" sz="1300" b="0" u="none" strike="noStrike">
               <a:solidFill>
@@ -15545,7 +16529,7 @@
         <p:spPr>
           <a:xfrm>
             <a:off x="822960" y="1853280"/>
-            <a:ext cx="2955240" cy="808920"/>
+            <a:ext cx="2954880" cy="808560"/>
           </a:xfrm>
           <a:prstGeom prst="rect">
             <a:avLst/>
@@ -15701,8 +16685,8 @@
         </p:nvSpPr>
         <p:spPr>
           <a:xfrm rot="21593400">
-            <a:off x="718200" y="3206880"/>
-            <a:ext cx="2959200" cy="290160"/>
+            <a:off x="717840" y="3206880"/>
+            <a:ext cx="2958840" cy="289800"/>
           </a:xfrm>
           <a:prstGeom prst="rect">
             <a:avLst/>
@@ -15763,7 +16747,7 @@
         <p:spPr>
           <a:xfrm>
             <a:off x="827280" y="3521160"/>
-            <a:ext cx="2955240" cy="1049040"/>
+            <a:ext cx="2954880" cy="1048680"/>
           </a:xfrm>
           <a:prstGeom prst="rect">
             <a:avLst/>
@@ -16005,7 +16989,7 @@
         <p:spPr>
           <a:xfrm>
             <a:off x="720000" y="4964040"/>
-            <a:ext cx="2955240" cy="290160"/>
+            <a:ext cx="2954880" cy="289800"/>
           </a:xfrm>
           <a:prstGeom prst="rect">
             <a:avLst/>
@@ -16066,7 +17050,7 @@
         <p:spPr>
           <a:xfrm>
             <a:off x="822960" y="5284080"/>
-            <a:ext cx="2955240" cy="726120"/>
+            <a:ext cx="2954880" cy="725760"/>
           </a:xfrm>
           <a:prstGeom prst="rect">
             <a:avLst/>
@@ -16215,7 +17199,7 @@
         <p:spPr>
           <a:xfrm>
             <a:off x="4183200" y="1260000"/>
-            <a:ext cx="7472880" cy="4549320"/>
+            <a:ext cx="7472520" cy="4548960"/>
           </a:xfrm>
           <a:prstGeom prst="rect">
             <a:avLst/>
@@ -16235,7 +17219,7 @@
         <p:spPr>
           <a:xfrm>
             <a:off x="4892040" y="5884920"/>
-            <a:ext cx="6764040" cy="317520"/>
+            <a:ext cx="6763680" cy="317160"/>
           </a:xfrm>
           <a:prstGeom prst="rect">
             <a:avLst/>
@@ -16296,7 +17280,7 @@
         <p:spPr>
           <a:xfrm>
             <a:off x="548640" y="6473880"/>
-            <a:ext cx="8684280" cy="271800"/>
+            <a:ext cx="8683920" cy="271440"/>
           </a:xfrm>
           <a:prstGeom prst="rect">
             <a:avLst/>
@@ -16357,7 +17341,7 @@
         <p:spPr>
           <a:xfrm>
             <a:off x="11003040" y="6473880"/>
-            <a:ext cx="820440" cy="271800"/>
+            <a:ext cx="820080" cy="271440"/>
           </a:xfrm>
           <a:prstGeom prst="rect">
             <a:avLst/>
@@ -16455,7 +17439,7 @@
         <p:spPr>
           <a:xfrm>
             <a:off x="548640" y="384120"/>
-            <a:ext cx="7312680" cy="290160"/>
+            <a:ext cx="7312320" cy="289800"/>
           </a:xfrm>
           <a:prstGeom prst="rect">
             <a:avLst/>
@@ -16516,7 +17500,7 @@
         <p:spPr>
           <a:xfrm>
             <a:off x="548640" y="658440"/>
-            <a:ext cx="9507240" cy="866160"/>
+            <a:ext cx="9506880" cy="865800"/>
           </a:xfrm>
           <a:prstGeom prst="rect">
             <a:avLst/>
@@ -16581,7 +17565,7 @@
         <p:spPr>
           <a:xfrm>
             <a:off x="11140200" y="365760"/>
-            <a:ext cx="655920" cy="655920"/>
+            <a:ext cx="655560" cy="655560"/>
           </a:xfrm>
           <a:prstGeom prst="rect">
             <a:avLst/>
@@ -16601,7 +17585,7 @@
         <p:spPr>
           <a:xfrm>
             <a:off x="548640" y="1691640"/>
-            <a:ext cx="3609360" cy="3700800"/>
+            <a:ext cx="3609000" cy="3700440"/>
           </a:xfrm>
           <a:prstGeom prst="roundRect">
             <a:avLst>
@@ -16656,7 +17640,7 @@
         <p:spPr>
           <a:xfrm>
             <a:off x="822960" y="1920240"/>
-            <a:ext cx="3060720" cy="454680"/>
+            <a:ext cx="3060360" cy="454320"/>
           </a:xfrm>
           <a:prstGeom prst="roundRect">
             <a:avLst>
@@ -16701,7 +17685,7 @@
         <p:spPr>
           <a:xfrm>
             <a:off x="822960" y="1920240"/>
-            <a:ext cx="3060720" cy="454680"/>
+            <a:ext cx="3060360" cy="454320"/>
           </a:xfrm>
           <a:prstGeom prst="rect">
             <a:avLst/>
@@ -16740,7 +17724,7 @@
                 <a:latin typeface="Calibri"/>
                 <a:ea typeface="Calibri"/>
               </a:rPr>
-              <a:t>GDPR</a:t>
+              <a:t>RGPD</a:t>
             </a:r>
             <a:endParaRPr lang="fr-FR" sz="1600" b="0" u="none" strike="noStrike">
               <a:solidFill>
@@ -16762,7 +17746,7 @@
         <p:spPr>
           <a:xfrm>
             <a:off x="822960" y="2560320"/>
-            <a:ext cx="3060720" cy="2603520"/>
+            <a:ext cx="3060360" cy="2603160"/>
           </a:xfrm>
           <a:prstGeom prst="rect">
             <a:avLst/>
@@ -16980,7 +17964,7 @@
         <p:spPr>
           <a:xfrm>
             <a:off x="4380120" y="1691640"/>
-            <a:ext cx="3609360" cy="3700800"/>
+            <a:ext cx="3609000" cy="3700440"/>
           </a:xfrm>
           <a:prstGeom prst="roundRect">
             <a:avLst>
@@ -17035,7 +18019,7 @@
         <p:spPr>
           <a:xfrm>
             <a:off x="4654440" y="1920240"/>
-            <a:ext cx="3060720" cy="454680"/>
+            <a:ext cx="3060360" cy="454320"/>
           </a:xfrm>
           <a:prstGeom prst="roundRect">
             <a:avLst>
@@ -17080,7 +18064,7 @@
         <p:spPr>
           <a:xfrm>
             <a:off x="4654440" y="1920240"/>
-            <a:ext cx="3060720" cy="454680"/>
+            <a:ext cx="3060360" cy="454320"/>
           </a:xfrm>
           <a:prstGeom prst="rect">
             <a:avLst/>
@@ -17141,7 +18125,7 @@
         <p:spPr>
           <a:xfrm>
             <a:off x="4654440" y="2560320"/>
-            <a:ext cx="3060720" cy="2603520"/>
+            <a:ext cx="3060360" cy="2603160"/>
           </a:xfrm>
           <a:prstGeom prst="rect">
             <a:avLst/>
@@ -17289,7 +18273,7 @@
         <p:spPr>
           <a:xfrm>
             <a:off x="8211240" y="1691640"/>
-            <a:ext cx="3609360" cy="3700800"/>
+            <a:ext cx="3609000" cy="3700440"/>
           </a:xfrm>
           <a:prstGeom prst="roundRect">
             <a:avLst>
@@ -17344,7 +18328,7 @@
         <p:spPr>
           <a:xfrm>
             <a:off x="8485560" y="1920240"/>
-            <a:ext cx="3060720" cy="454680"/>
+            <a:ext cx="3060360" cy="454320"/>
           </a:xfrm>
           <a:prstGeom prst="roundRect">
             <a:avLst>
@@ -17389,7 +18373,7 @@
         <p:spPr>
           <a:xfrm>
             <a:off x="8485560" y="1920240"/>
-            <a:ext cx="3060720" cy="454680"/>
+            <a:ext cx="3060360" cy="454320"/>
           </a:xfrm>
           <a:prstGeom prst="rect">
             <a:avLst/>
@@ -17450,7 +18434,7 @@
         <p:spPr>
           <a:xfrm>
             <a:off x="8485560" y="2560320"/>
-            <a:ext cx="3060720" cy="2603520"/>
+            <a:ext cx="3060360" cy="2603160"/>
           </a:xfrm>
           <a:prstGeom prst="rect">
             <a:avLst/>
@@ -17656,7 +18640,7 @@
         <p:spPr>
           <a:xfrm>
             <a:off x="609120" y="5532120"/>
-            <a:ext cx="11089080" cy="655920"/>
+            <a:ext cx="11088720" cy="655560"/>
           </a:xfrm>
           <a:prstGeom prst="roundRect">
             <a:avLst>
@@ -17704,7 +18688,7 @@
         <p:spPr>
           <a:xfrm>
             <a:off x="822960" y="5580000"/>
-            <a:ext cx="10513080" cy="538200"/>
+            <a:ext cx="10512720" cy="537840"/>
           </a:xfrm>
           <a:prstGeom prst="rect">
             <a:avLst/>
@@ -17801,7 +18785,7 @@
         <p:spPr>
           <a:xfrm>
             <a:off x="548640" y="6473880"/>
-            <a:ext cx="8684280" cy="271800"/>
+            <a:ext cx="8683920" cy="271440"/>
           </a:xfrm>
           <a:prstGeom prst="rect">
             <a:avLst/>
@@ -17862,7 +18846,7 @@
         <p:spPr>
           <a:xfrm>
             <a:off x="11003040" y="6473880"/>
-            <a:ext cx="820440" cy="271800"/>
+            <a:ext cx="820080" cy="271440"/>
           </a:xfrm>
           <a:prstGeom prst="rect">
             <a:avLst/>
@@ -17960,7 +18944,7 @@
         <p:spPr>
           <a:xfrm>
             <a:off x="548640" y="384120"/>
-            <a:ext cx="7312680" cy="290160"/>
+            <a:ext cx="7312320" cy="289800"/>
           </a:xfrm>
           <a:prstGeom prst="rect">
             <a:avLst/>
@@ -18021,7 +19005,7 @@
         <p:spPr>
           <a:xfrm>
             <a:off x="548640" y="658440"/>
-            <a:ext cx="9690120" cy="866160"/>
+            <a:ext cx="9689760" cy="865800"/>
           </a:xfrm>
           <a:prstGeom prst="rect">
             <a:avLst/>
@@ -18086,7 +19070,7 @@
         <p:spPr>
           <a:xfrm>
             <a:off x="11140200" y="365760"/>
-            <a:ext cx="655920" cy="655920"/>
+            <a:ext cx="655560" cy="655560"/>
           </a:xfrm>
           <a:prstGeom prst="rect">
             <a:avLst/>
@@ -18106,7 +19090,7 @@
         <p:spPr>
           <a:xfrm>
             <a:off x="548640" y="1783080"/>
-            <a:ext cx="2649240" cy="1049040"/>
+            <a:ext cx="2648880" cy="1048680"/>
           </a:xfrm>
           <a:prstGeom prst="roundRect">
             <a:avLst>
@@ -18161,7 +19145,7 @@
         <p:spPr>
           <a:xfrm>
             <a:off x="731520" y="1892880"/>
-            <a:ext cx="2283480" cy="271800"/>
+            <a:ext cx="2283120" cy="271440"/>
           </a:xfrm>
           <a:prstGeom prst="rect">
             <a:avLst/>
@@ -18222,7 +19206,7 @@
         <p:spPr>
           <a:xfrm>
             <a:off x="731520" y="2185560"/>
-            <a:ext cx="2283480" cy="591840"/>
+            <a:ext cx="2283120" cy="591480"/>
           </a:xfrm>
           <a:prstGeom prst="rect">
             <a:avLst/>
@@ -18283,7 +19267,7 @@
         <p:spPr>
           <a:xfrm>
             <a:off x="3401640" y="1783080"/>
-            <a:ext cx="2649240" cy="1049040"/>
+            <a:ext cx="2648880" cy="1048680"/>
           </a:xfrm>
           <a:prstGeom prst="roundRect">
             <a:avLst>
@@ -18338,7 +19322,7 @@
         <p:spPr>
           <a:xfrm>
             <a:off x="3584520" y="1892880"/>
-            <a:ext cx="2283480" cy="271800"/>
+            <a:ext cx="2283120" cy="271440"/>
           </a:xfrm>
           <a:prstGeom prst="rect">
             <a:avLst/>
@@ -18398,8 +19382,8 @@
         </p:nvSpPr>
         <p:spPr>
           <a:xfrm>
-            <a:off x="3584520" y="2185560"/>
-            <a:ext cx="2283480" cy="591840"/>
+            <a:off x="3584520" y="2160000"/>
+            <a:ext cx="2355480" cy="617040"/>
           </a:xfrm>
           <a:prstGeom prst="rect">
             <a:avLst/>
@@ -18438,7 +19422,37 @@
                 <a:latin typeface="Calibri"/>
                 <a:ea typeface="Calibri"/>
               </a:rPr>
-              <a:t>Évaluation périodique des biais algorithmiques </a:t>
+              <a:t>Évaluation périodique des biais </a:t>
+            </a:r>
+            <a:endParaRPr lang="fr-FR" sz="1050" b="0" u="none" strike="noStrike">
+              <a:solidFill>
+                <a:srgbClr val="000000"/>
+              </a:solidFill>
+              <a:effectLst/>
+              <a:uFillTx/>
+              <a:latin typeface="Arial"/>
+            </a:endParaRPr>
+          </a:p>
+          <a:p>
+            <a:pPr defTabSz="914400">
+              <a:lnSpc>
+                <a:spcPct val="100000"/>
+              </a:lnSpc>
+              <a:tabLst>
+                <a:tab pos="0" algn="l"/>
+              </a:tabLst>
+            </a:pPr>
+            <a:r>
+              <a:rPr lang="fr-FR" sz="1050" b="0" u="none" strike="noStrike">
+                <a:solidFill>
+                  <a:srgbClr val="1B2A4A"/>
+                </a:solidFill>
+                <a:effectLst/>
+                <a:uFillTx/>
+                <a:latin typeface="Calibri"/>
+                <a:ea typeface="Calibri"/>
+              </a:rPr>
+              <a:t>algorithmiques </a:t>
             </a:r>
             <a:endParaRPr lang="fr-FR" sz="1050" b="0" u="none" strike="noStrike">
               <a:solidFill>
@@ -18490,7 +19504,7 @@
         <p:spPr>
           <a:xfrm>
             <a:off x="6254640" y="1783080"/>
-            <a:ext cx="2649240" cy="1049040"/>
+            <a:ext cx="2648880" cy="1048680"/>
           </a:xfrm>
           <a:prstGeom prst="roundRect">
             <a:avLst>
@@ -18545,7 +19559,7 @@
         <p:spPr>
           <a:xfrm>
             <a:off x="6437520" y="1892880"/>
-            <a:ext cx="2283480" cy="271800"/>
+            <a:ext cx="2283120" cy="271440"/>
           </a:xfrm>
           <a:prstGeom prst="rect">
             <a:avLst/>
@@ -18606,7 +19620,7 @@
         <p:spPr>
           <a:xfrm>
             <a:off x="6437520" y="2185560"/>
-            <a:ext cx="2381760" cy="591840"/>
+            <a:ext cx="2381400" cy="591480"/>
           </a:xfrm>
           <a:prstGeom prst="rect">
             <a:avLst/>
@@ -18667,7 +19681,7 @@
         <p:spPr>
           <a:xfrm>
             <a:off x="9107280" y="1783080"/>
-            <a:ext cx="2649240" cy="1049040"/>
+            <a:ext cx="2648880" cy="1048680"/>
           </a:xfrm>
           <a:prstGeom prst="roundRect">
             <a:avLst>
@@ -18722,7 +19736,7 @@
         <p:spPr>
           <a:xfrm>
             <a:off x="9290160" y="1892880"/>
-            <a:ext cx="2283480" cy="271800"/>
+            <a:ext cx="2283120" cy="271440"/>
           </a:xfrm>
           <a:prstGeom prst="rect">
             <a:avLst/>
@@ -18783,7 +19797,7 @@
         <p:spPr>
           <a:xfrm>
             <a:off x="9290160" y="2185560"/>
-            <a:ext cx="2409840" cy="591840"/>
+            <a:ext cx="2409480" cy="591480"/>
           </a:xfrm>
           <a:prstGeom prst="rect">
             <a:avLst/>
@@ -19465,19 +20479,7 @@
                           <a:latin typeface="Calibri"/>
                           <a:ea typeface="Calibri"/>
                         </a:rPr>
-                        <a:t>MO (R) → MRM (A)   </a:t>
-                      </a:r>
-                      <a:r>
-                        <a:rPr lang="en-US" sz="1100" b="1" u="none" strike="noStrike">
-                          <a:solidFill>
-                            <a:srgbClr val="1B2A4A"/>
-                          </a:solidFill>
-                          <a:effectLst/>
-                          <a:uFillTx/>
-                          <a:latin typeface="Calibri"/>
-                          <a:ea typeface="Calibri"/>
-                        </a:rPr>
-                        <a:t>[ CDO (C) ]</a:t>
+                        <a:t>MO (R) → MRM (A)   [ CDO (C) ]</a:t>
                       </a:r>
                       <a:endParaRPr lang="fr-FR" sz="1100" b="0" u="none" strike="noStrike">
                         <a:solidFill>
@@ -19733,7 +20735,7 @@
         <p:spPr>
           <a:xfrm>
             <a:off x="548640" y="6035040"/>
-            <a:ext cx="11089080" cy="317520"/>
+            <a:ext cx="11088720" cy="317160"/>
           </a:xfrm>
           <a:prstGeom prst="rect">
             <a:avLst/>
@@ -19794,7 +20796,7 @@
         <p:spPr>
           <a:xfrm>
             <a:off x="548640" y="6473880"/>
-            <a:ext cx="8684280" cy="271800"/>
+            <a:ext cx="8683920" cy="271440"/>
           </a:xfrm>
           <a:prstGeom prst="rect">
             <a:avLst/>
@@ -19855,7 +20857,7 @@
         <p:spPr>
           <a:xfrm>
             <a:off x="11003040" y="6473880"/>
-            <a:ext cx="820440" cy="271800"/>
+            <a:ext cx="820080" cy="271440"/>
           </a:xfrm>
           <a:prstGeom prst="rect">
             <a:avLst/>
@@ -19953,7 +20955,7 @@
         <p:spPr>
           <a:xfrm>
             <a:off x="548640" y="384120"/>
-            <a:ext cx="7312680" cy="290160"/>
+            <a:ext cx="7312320" cy="289800"/>
           </a:xfrm>
           <a:prstGeom prst="rect">
             <a:avLst/>
@@ -20014,7 +21016,7 @@
         <p:spPr>
           <a:xfrm>
             <a:off x="548640" y="658440"/>
-            <a:ext cx="9690120" cy="866160"/>
+            <a:ext cx="9689760" cy="865800"/>
           </a:xfrm>
           <a:prstGeom prst="rect">
             <a:avLst/>
@@ -20079,7 +21081,7 @@
         <p:spPr>
           <a:xfrm>
             <a:off x="11140200" y="365760"/>
-            <a:ext cx="655920" cy="655920"/>
+            <a:ext cx="655560" cy="655560"/>
           </a:xfrm>
           <a:prstGeom prst="rect">
             <a:avLst/>
@@ -20099,7 +21101,7 @@
         <p:spPr>
           <a:xfrm>
             <a:off x="548640" y="1600200"/>
-            <a:ext cx="5758200" cy="317520"/>
+            <a:ext cx="5757840" cy="317160"/>
           </a:xfrm>
           <a:prstGeom prst="rect">
             <a:avLst/>
@@ -20160,7 +21162,7 @@
         <p:spPr>
           <a:xfrm>
             <a:off x="548640" y="2011680"/>
-            <a:ext cx="5758200" cy="692280"/>
+            <a:ext cx="5757840" cy="691920"/>
           </a:xfrm>
           <a:prstGeom prst="roundRect">
             <a:avLst>
@@ -20215,7 +21217,7 @@
         <p:spPr>
           <a:xfrm>
             <a:off x="713160" y="2139840"/>
-            <a:ext cx="436320" cy="436320"/>
+            <a:ext cx="435960" cy="435960"/>
           </a:xfrm>
           <a:prstGeom prst="ellipse">
             <a:avLst/>
@@ -20258,7 +21260,7 @@
         <p:spPr>
           <a:xfrm>
             <a:off x="713160" y="2139840"/>
-            <a:ext cx="436320" cy="436320"/>
+            <a:ext cx="435960" cy="435960"/>
           </a:xfrm>
           <a:prstGeom prst="rect">
             <a:avLst/>
@@ -20319,7 +21321,7 @@
         <p:spPr>
           <a:xfrm>
             <a:off x="1325880" y="2084760"/>
-            <a:ext cx="4752360" cy="271800"/>
+            <a:ext cx="4752000" cy="271440"/>
           </a:xfrm>
           <a:prstGeom prst="rect">
             <a:avLst/>
@@ -20380,7 +21382,7 @@
         <p:spPr>
           <a:xfrm>
             <a:off x="1325880" y="2359080"/>
-            <a:ext cx="4752360" cy="290160"/>
+            <a:ext cx="4752000" cy="289800"/>
           </a:xfrm>
           <a:prstGeom prst="rect">
             <a:avLst/>
@@ -20441,7 +21443,7 @@
         <p:spPr>
           <a:xfrm>
             <a:off x="548640" y="2797920"/>
-            <a:ext cx="5758200" cy="692280"/>
+            <a:ext cx="5757840" cy="691920"/>
           </a:xfrm>
           <a:prstGeom prst="roundRect">
             <a:avLst>
@@ -20496,7 +21498,7 @@
         <p:spPr>
           <a:xfrm>
             <a:off x="713160" y="2926080"/>
-            <a:ext cx="436320" cy="436320"/>
+            <a:ext cx="435960" cy="435960"/>
           </a:xfrm>
           <a:prstGeom prst="ellipse">
             <a:avLst/>
@@ -20539,7 +21541,7 @@
         <p:spPr>
           <a:xfrm>
             <a:off x="713160" y="2926080"/>
-            <a:ext cx="436320" cy="436320"/>
+            <a:ext cx="435960" cy="435960"/>
           </a:xfrm>
           <a:prstGeom prst="rect">
             <a:avLst/>
@@ -20600,7 +21602,7 @@
         <p:spPr>
           <a:xfrm>
             <a:off x="1325880" y="2871360"/>
-            <a:ext cx="4752360" cy="271800"/>
+            <a:ext cx="4752000" cy="271440"/>
           </a:xfrm>
           <a:prstGeom prst="rect">
             <a:avLst/>
@@ -20661,7 +21663,7 @@
         <p:spPr>
           <a:xfrm>
             <a:off x="1325880" y="3145680"/>
-            <a:ext cx="4752360" cy="290160"/>
+            <a:ext cx="4752000" cy="289800"/>
           </a:xfrm>
           <a:prstGeom prst="rect">
             <a:avLst/>
@@ -20722,7 +21724,7 @@
         <p:spPr>
           <a:xfrm>
             <a:off x="548640" y="3584520"/>
-            <a:ext cx="5758200" cy="692280"/>
+            <a:ext cx="5757840" cy="691920"/>
           </a:xfrm>
           <a:prstGeom prst="roundRect">
             <a:avLst>
@@ -20777,7 +21779,7 @@
         <p:spPr>
           <a:xfrm>
             <a:off x="713160" y="3712320"/>
-            <a:ext cx="436320" cy="436320"/>
+            <a:ext cx="435960" cy="435960"/>
           </a:xfrm>
           <a:prstGeom prst="ellipse">
             <a:avLst/>
@@ -20820,7 +21822,7 @@
         <p:spPr>
           <a:xfrm>
             <a:off x="713160" y="3712320"/>
-            <a:ext cx="436320" cy="436320"/>
+            <a:ext cx="435960" cy="435960"/>
           </a:xfrm>
           <a:prstGeom prst="rect">
             <a:avLst/>
@@ -20881,7 +21883,7 @@
         <p:spPr>
           <a:xfrm>
             <a:off x="1325880" y="3657600"/>
-            <a:ext cx="4752360" cy="271800"/>
+            <a:ext cx="4752000" cy="271440"/>
           </a:xfrm>
           <a:prstGeom prst="rect">
             <a:avLst/>
@@ -20942,7 +21944,7 @@
         <p:spPr>
           <a:xfrm>
             <a:off x="1325880" y="3931920"/>
-            <a:ext cx="4752360" cy="290160"/>
+            <a:ext cx="4752000" cy="289800"/>
           </a:xfrm>
           <a:prstGeom prst="rect">
             <a:avLst/>
@@ -21003,7 +22005,7 @@
         <p:spPr>
           <a:xfrm>
             <a:off x="548640" y="4370760"/>
-            <a:ext cx="5758200" cy="692280"/>
+            <a:ext cx="5757840" cy="691920"/>
           </a:xfrm>
           <a:prstGeom prst="roundRect">
             <a:avLst>
@@ -21058,7 +22060,7 @@
         <p:spPr>
           <a:xfrm>
             <a:off x="713160" y="4498920"/>
-            <a:ext cx="436320" cy="436320"/>
+            <a:ext cx="435960" cy="435960"/>
           </a:xfrm>
           <a:prstGeom prst="ellipse">
             <a:avLst/>
@@ -21101,7 +22103,7 @@
         <p:spPr>
           <a:xfrm>
             <a:off x="713160" y="4498920"/>
-            <a:ext cx="436320" cy="436320"/>
+            <a:ext cx="435960" cy="435960"/>
           </a:xfrm>
           <a:prstGeom prst="rect">
             <a:avLst/>
@@ -21162,7 +22164,7 @@
         <p:spPr>
           <a:xfrm>
             <a:off x="1325880" y="4443840"/>
-            <a:ext cx="4752360" cy="271800"/>
+            <a:ext cx="4752000" cy="271440"/>
           </a:xfrm>
           <a:prstGeom prst="rect">
             <a:avLst/>
@@ -21223,7 +22225,7 @@
         <p:spPr>
           <a:xfrm>
             <a:off x="1325880" y="4718160"/>
-            <a:ext cx="4752360" cy="290160"/>
+            <a:ext cx="4752000" cy="289800"/>
           </a:xfrm>
           <a:prstGeom prst="rect">
             <a:avLst/>
@@ -21284,7 +22286,7 @@
         <p:spPr>
           <a:xfrm>
             <a:off x="548640" y="5157360"/>
-            <a:ext cx="5758200" cy="692280"/>
+            <a:ext cx="5757840" cy="691920"/>
           </a:xfrm>
           <a:prstGeom prst="roundRect">
             <a:avLst>
@@ -21339,7 +22341,7 @@
         <p:spPr>
           <a:xfrm>
             <a:off x="713160" y="5285160"/>
-            <a:ext cx="436320" cy="436320"/>
+            <a:ext cx="435960" cy="435960"/>
           </a:xfrm>
           <a:prstGeom prst="ellipse">
             <a:avLst/>
@@ -21382,7 +22384,7 @@
         <p:spPr>
           <a:xfrm>
             <a:off x="713160" y="5285160"/>
-            <a:ext cx="436320" cy="436320"/>
+            <a:ext cx="435960" cy="435960"/>
           </a:xfrm>
           <a:prstGeom prst="rect">
             <a:avLst/>
@@ -21443,7 +22445,7 @@
         <p:spPr>
           <a:xfrm>
             <a:off x="1325880" y="5230440"/>
-            <a:ext cx="4752360" cy="271800"/>
+            <a:ext cx="4752000" cy="271440"/>
           </a:xfrm>
           <a:prstGeom prst="rect">
             <a:avLst/>
@@ -21504,7 +22506,7 @@
         <p:spPr>
           <a:xfrm>
             <a:off x="1325880" y="5504760"/>
-            <a:ext cx="4752360" cy="290160"/>
+            <a:ext cx="4752000" cy="289800"/>
           </a:xfrm>
           <a:prstGeom prst="rect">
             <a:avLst/>
@@ -21649,7 +22651,7 @@
         <p:spPr>
           <a:xfrm>
             <a:off x="6583680" y="1600200"/>
-            <a:ext cx="5072400" cy="317520"/>
+            <a:ext cx="5072040" cy="317160"/>
           </a:xfrm>
           <a:prstGeom prst="rect">
             <a:avLst/>
@@ -21688,7 +22690,31 @@
                 <a:latin typeface="Calibri"/>
                 <a:ea typeface="Calibri"/>
               </a:rPr>
-              <a:t>Pilote : Le système de recommandation</a:t>
+              <a:t>Pilote : Le système de recommandation (</a:t>
+            </a:r>
+            <a:r>
+              <a:rPr lang="fr-FR" sz="1400" b="1" i="1" u="none" strike="noStrike">
+                <a:solidFill>
+                  <a:srgbClr val="1B2A4A"/>
+                </a:solidFill>
+                <a:effectLst/>
+                <a:uFillTx/>
+                <a:latin typeface="Calibri"/>
+                <a:ea typeface="Calibri"/>
+              </a:rPr>
+              <a:t>Product Development</a:t>
+            </a:r>
+            <a:r>
+              <a:rPr lang="fr-FR" sz="1400" b="1" u="none" strike="noStrike">
+                <a:solidFill>
+                  <a:srgbClr val="1B2A4A"/>
+                </a:solidFill>
+                <a:effectLst/>
+                <a:uFillTx/>
+                <a:latin typeface="Calibri"/>
+                <a:ea typeface="Calibri"/>
+              </a:rPr>
+              <a:t>)</a:t>
             </a:r>
             <a:endParaRPr lang="fr-FR" sz="1400" b="0" u="none" strike="noStrike">
               <a:solidFill>
@@ -21710,7 +22736,7 @@
         <p:spPr>
           <a:xfrm>
             <a:off x="6583680" y="2011680"/>
-            <a:ext cx="5072400" cy="1003320"/>
+            <a:ext cx="5072040" cy="1002960"/>
           </a:xfrm>
           <a:prstGeom prst="roundRect">
             <a:avLst>
@@ -21765,7 +22791,7 @@
         <p:spPr>
           <a:xfrm>
             <a:off x="6812280" y="2121480"/>
-            <a:ext cx="4615200" cy="408960"/>
+            <a:ext cx="4614840" cy="408600"/>
           </a:xfrm>
           <a:prstGeom prst="rect">
             <a:avLst/>
@@ -21826,7 +22852,7 @@
         <p:spPr>
           <a:xfrm>
             <a:off x="6812280" y="2541960"/>
-            <a:ext cx="4615200" cy="436320"/>
+            <a:ext cx="4614840" cy="435960"/>
           </a:xfrm>
           <a:prstGeom prst="rect">
             <a:avLst/>
@@ -21941,7 +22967,7 @@
         <p:spPr>
           <a:xfrm>
             <a:off x="6583680" y="3154680"/>
-            <a:ext cx="5072400" cy="1186200"/>
+            <a:ext cx="5072040" cy="1185840"/>
           </a:xfrm>
           <a:prstGeom prst="roundRect">
             <a:avLst>
@@ -21996,7 +23022,7 @@
         <p:spPr>
           <a:xfrm>
             <a:off x="6812280" y="3273480"/>
-            <a:ext cx="4615200" cy="271800"/>
+            <a:ext cx="4614840" cy="271440"/>
           </a:xfrm>
           <a:prstGeom prst="rect">
             <a:avLst/>
@@ -22057,7 +23083,7 @@
         <p:spPr>
           <a:xfrm>
             <a:off x="6812280" y="3566160"/>
-            <a:ext cx="4615200" cy="729000"/>
+            <a:ext cx="4614840" cy="728640"/>
           </a:xfrm>
           <a:prstGeom prst="rect">
             <a:avLst/>
@@ -22160,7 +23186,7 @@
         <p:spPr>
           <a:xfrm>
             <a:off x="6583680" y="4480560"/>
-            <a:ext cx="5072400" cy="1186200"/>
+            <a:ext cx="5072040" cy="1185840"/>
           </a:xfrm>
           <a:prstGeom prst="roundRect">
             <a:avLst>
@@ -22215,7 +23241,7 @@
         <p:spPr>
           <a:xfrm>
             <a:off x="6812280" y="4599360"/>
-            <a:ext cx="4615200" cy="271800"/>
+            <a:ext cx="4614840" cy="271440"/>
           </a:xfrm>
           <a:prstGeom prst="rect">
             <a:avLst/>
@@ -22276,7 +23302,7 @@
         <p:spPr>
           <a:xfrm>
             <a:off x="6812280" y="4892040"/>
-            <a:ext cx="4615200" cy="506160"/>
+            <a:ext cx="4614840" cy="505800"/>
           </a:xfrm>
           <a:prstGeom prst="rect">
             <a:avLst/>
@@ -22367,7 +23393,7 @@
         <p:spPr>
           <a:xfrm>
             <a:off x="6583680" y="5806440"/>
-            <a:ext cx="5072400" cy="619200"/>
+            <a:ext cx="5072040" cy="618840"/>
           </a:xfrm>
           <a:prstGeom prst="roundRect">
             <a:avLst>
@@ -22415,7 +23441,7 @@
         <p:spPr>
           <a:xfrm>
             <a:off x="6784920" y="5806440"/>
-            <a:ext cx="4871160" cy="619200"/>
+            <a:ext cx="4870800" cy="618840"/>
           </a:xfrm>
           <a:prstGeom prst="rect">
             <a:avLst/>
@@ -22536,7 +23562,7 @@
         <p:spPr>
           <a:xfrm>
             <a:off x="548640" y="6473880"/>
-            <a:ext cx="8684280" cy="271800"/>
+            <a:ext cx="8683920" cy="271440"/>
           </a:xfrm>
           <a:prstGeom prst="rect">
             <a:avLst/>
@@ -22597,7 +23623,7 @@
         <p:spPr>
           <a:xfrm>
             <a:off x="11003040" y="6473880"/>
-            <a:ext cx="820440" cy="271800"/>
+            <a:ext cx="820080" cy="271440"/>
           </a:xfrm>
           <a:prstGeom prst="rect">
             <a:avLst/>
@@ -22695,7 +23721,7 @@
         <p:spPr>
           <a:xfrm>
             <a:off x="548640" y="384120"/>
-            <a:ext cx="7312680" cy="290160"/>
+            <a:ext cx="7312320" cy="289800"/>
           </a:xfrm>
           <a:prstGeom prst="rect">
             <a:avLst/>
@@ -22756,7 +23782,7 @@
         <p:spPr>
           <a:xfrm>
             <a:off x="548640" y="658440"/>
-            <a:ext cx="9690120" cy="866160"/>
+            <a:ext cx="9689760" cy="865800"/>
           </a:xfrm>
           <a:prstGeom prst="rect">
             <a:avLst/>
@@ -22821,7 +23847,7 @@
         <p:spPr>
           <a:xfrm>
             <a:off x="11140200" y="365760"/>
-            <a:ext cx="655920" cy="655920"/>
+            <a:ext cx="655560" cy="655560"/>
           </a:xfrm>
           <a:prstGeom prst="rect">
             <a:avLst/>
@@ -22841,7 +23867,7 @@
         <p:spPr>
           <a:xfrm>
             <a:off x="1658160" y="3781080"/>
-            <a:ext cx="8872920" cy="24840"/>
+            <a:ext cx="8872560" cy="24480"/>
           </a:xfrm>
           <a:prstGeom prst="rect">
             <a:avLst/>
@@ -22884,7 +23910,7 @@
         <p:spPr>
           <a:xfrm>
             <a:off x="540000" y="1691640"/>
-            <a:ext cx="2338200" cy="1780560"/>
+            <a:ext cx="2337840" cy="1780200"/>
           </a:xfrm>
           <a:prstGeom prst="roundRect">
             <a:avLst>
@@ -22939,7 +23965,7 @@
         <p:spPr>
           <a:xfrm>
             <a:off x="648000" y="1828800"/>
-            <a:ext cx="1779840" cy="317520"/>
+            <a:ext cx="1779480" cy="317160"/>
           </a:xfrm>
           <a:prstGeom prst="rect">
             <a:avLst/>
@@ -23000,7 +24026,7 @@
         <p:spPr>
           <a:xfrm>
             <a:off x="648000" y="2176200"/>
-            <a:ext cx="2173680" cy="866160"/>
+            <a:ext cx="2173320" cy="865800"/>
           </a:xfrm>
           <a:prstGeom prst="rect">
             <a:avLst/>
@@ -23091,7 +24117,7 @@
         <p:spPr>
           <a:xfrm>
             <a:off x="648000" y="3090600"/>
-            <a:ext cx="1779840" cy="317520"/>
+            <a:ext cx="1779480" cy="317160"/>
           </a:xfrm>
           <a:prstGeom prst="rect">
             <a:avLst/>
@@ -23152,7 +24178,7 @@
         <p:spPr>
           <a:xfrm>
             <a:off x="1511640" y="3648600"/>
-            <a:ext cx="290160" cy="290160"/>
+            <a:ext cx="289800" cy="289800"/>
           </a:xfrm>
           <a:prstGeom prst="ellipse">
             <a:avLst/>
@@ -23198,7 +24224,7 @@
         <p:spPr>
           <a:xfrm>
             <a:off x="676800" y="3996000"/>
-            <a:ext cx="1960200" cy="317520"/>
+            <a:ext cx="1959840" cy="317160"/>
           </a:xfrm>
           <a:prstGeom prst="rect">
             <a:avLst/>
@@ -23259,7 +24285,7 @@
         <p:spPr>
           <a:xfrm>
             <a:off x="3111480" y="1691640"/>
-            <a:ext cx="1960200" cy="1780560"/>
+            <a:ext cx="1959840" cy="1780200"/>
           </a:xfrm>
           <a:prstGeom prst="roundRect">
             <a:avLst>
@@ -23314,7 +24340,7 @@
         <p:spPr>
           <a:xfrm>
             <a:off x="3248640" y="1828800"/>
-            <a:ext cx="1685880" cy="317520"/>
+            <a:ext cx="1685520" cy="317160"/>
           </a:xfrm>
           <a:prstGeom prst="rect">
             <a:avLst/>
@@ -23375,7 +24401,7 @@
         <p:spPr>
           <a:xfrm>
             <a:off x="3248640" y="2176200"/>
-            <a:ext cx="1685880" cy="866160"/>
+            <a:ext cx="1685520" cy="865800"/>
           </a:xfrm>
           <a:prstGeom prst="rect">
             <a:avLst/>
@@ -23466,7 +24492,7 @@
         <p:spPr>
           <a:xfrm>
             <a:off x="3248640" y="3090600"/>
-            <a:ext cx="1685880" cy="317520"/>
+            <a:ext cx="1685520" cy="317160"/>
           </a:xfrm>
           <a:prstGeom prst="rect">
             <a:avLst/>
@@ -23527,7 +24553,7 @@
         <p:spPr>
           <a:xfrm>
             <a:off x="3730680" y="3648600"/>
-            <a:ext cx="290160" cy="290160"/>
+            <a:ext cx="289800" cy="289800"/>
           </a:xfrm>
           <a:prstGeom prst="ellipse">
             <a:avLst/>
@@ -23573,7 +24599,7 @@
         <p:spPr>
           <a:xfrm>
             <a:off x="2895480" y="3996000"/>
-            <a:ext cx="1960200" cy="317520"/>
+            <a:ext cx="1959840" cy="317160"/>
           </a:xfrm>
           <a:prstGeom prst="rect">
             <a:avLst/>
@@ -23634,7 +24660,7 @@
         <p:spPr>
           <a:xfrm>
             <a:off x="5294520" y="1691640"/>
-            <a:ext cx="1960200" cy="1780560"/>
+            <a:ext cx="1959840" cy="1780200"/>
           </a:xfrm>
           <a:prstGeom prst="roundRect">
             <a:avLst>
@@ -23689,7 +24715,7 @@
         <p:spPr>
           <a:xfrm>
             <a:off x="5431680" y="1828800"/>
-            <a:ext cx="1685880" cy="317520"/>
+            <a:ext cx="1685520" cy="317160"/>
           </a:xfrm>
           <a:prstGeom prst="rect">
             <a:avLst/>
@@ -23750,7 +24776,7 @@
         <p:spPr>
           <a:xfrm>
             <a:off x="5431680" y="2176200"/>
-            <a:ext cx="1685880" cy="866160"/>
+            <a:ext cx="1685520" cy="865800"/>
           </a:xfrm>
           <a:prstGeom prst="rect">
             <a:avLst/>
@@ -23841,7 +24867,7 @@
         <p:spPr>
           <a:xfrm>
             <a:off x="5431680" y="3090600"/>
-            <a:ext cx="1685880" cy="317520"/>
+            <a:ext cx="1685520" cy="317160"/>
           </a:xfrm>
           <a:prstGeom prst="rect">
             <a:avLst/>
@@ -23902,7 +24928,7 @@
         <p:spPr>
           <a:xfrm>
             <a:off x="5949720" y="3648600"/>
-            <a:ext cx="290160" cy="290160"/>
+            <a:ext cx="289800" cy="289800"/>
           </a:xfrm>
           <a:prstGeom prst="ellipse">
             <a:avLst/>
@@ -23948,7 +24974,7 @@
         <p:spPr>
           <a:xfrm>
             <a:off x="5114520" y="3996000"/>
-            <a:ext cx="1960200" cy="317520"/>
+            <a:ext cx="1959840" cy="317160"/>
           </a:xfrm>
           <a:prstGeom prst="rect">
             <a:avLst/>
@@ -24009,7 +25035,7 @@
         <p:spPr>
           <a:xfrm>
             <a:off x="7477200" y="1691640"/>
-            <a:ext cx="1960200" cy="1780560"/>
+            <a:ext cx="1959840" cy="1780200"/>
           </a:xfrm>
           <a:prstGeom prst="roundRect">
             <a:avLst>
@@ -24064,7 +25090,7 @@
         <p:spPr>
           <a:xfrm>
             <a:off x="7614360" y="1828800"/>
-            <a:ext cx="1685880" cy="317520"/>
+            <a:ext cx="1685520" cy="317160"/>
           </a:xfrm>
           <a:prstGeom prst="rect">
             <a:avLst/>
@@ -24125,7 +25151,7 @@
         <p:spPr>
           <a:xfrm>
             <a:off x="7614360" y="2176200"/>
-            <a:ext cx="1685880" cy="866160"/>
+            <a:ext cx="1685520" cy="865800"/>
           </a:xfrm>
           <a:prstGeom prst="rect">
             <a:avLst/>
@@ -24216,7 +25242,7 @@
         <p:spPr>
           <a:xfrm>
             <a:off x="7614360" y="3090600"/>
-            <a:ext cx="1685880" cy="317520"/>
+            <a:ext cx="1685520" cy="317160"/>
           </a:xfrm>
           <a:prstGeom prst="rect">
             <a:avLst/>
@@ -24277,7 +25303,7 @@
         <p:spPr>
           <a:xfrm>
             <a:off x="8168400" y="3648600"/>
-            <a:ext cx="290160" cy="290160"/>
+            <a:ext cx="289800" cy="289800"/>
           </a:xfrm>
           <a:prstGeom prst="ellipse">
             <a:avLst/>
@@ -24323,7 +25349,7 @@
         <p:spPr>
           <a:xfrm>
             <a:off x="7333200" y="3996000"/>
-            <a:ext cx="1960200" cy="317520"/>
+            <a:ext cx="1959840" cy="317160"/>
           </a:xfrm>
           <a:prstGeom prst="rect">
             <a:avLst/>
@@ -24384,7 +25410,7 @@
         <p:spPr>
           <a:xfrm>
             <a:off x="9660240" y="1691640"/>
-            <a:ext cx="2037960" cy="1780560"/>
+            <a:ext cx="2037600" cy="1780200"/>
           </a:xfrm>
           <a:prstGeom prst="roundRect">
             <a:avLst>
@@ -24439,7 +25465,7 @@
         <p:spPr>
           <a:xfrm>
             <a:off x="9797400" y="1828800"/>
-            <a:ext cx="1685880" cy="317520"/>
+            <a:ext cx="1685520" cy="317160"/>
           </a:xfrm>
           <a:prstGeom prst="rect">
             <a:avLst/>
@@ -24500,7 +25526,7 @@
         <p:spPr>
           <a:xfrm>
             <a:off x="9797400" y="2176200"/>
-            <a:ext cx="1900800" cy="866160"/>
+            <a:ext cx="1900440" cy="865800"/>
           </a:xfrm>
           <a:prstGeom prst="rect">
             <a:avLst/>
@@ -24591,7 +25617,7 @@
         <p:spPr>
           <a:xfrm>
             <a:off x="9797400" y="3090600"/>
-            <a:ext cx="1685880" cy="317520"/>
+            <a:ext cx="1685520" cy="317160"/>
           </a:xfrm>
           <a:prstGeom prst="rect">
             <a:avLst/>
@@ -24652,7 +25678,7 @@
         <p:spPr>
           <a:xfrm>
             <a:off x="10387440" y="3648600"/>
-            <a:ext cx="290160" cy="290160"/>
+            <a:ext cx="289800" cy="289800"/>
           </a:xfrm>
           <a:prstGeom prst="ellipse">
             <a:avLst/>
@@ -24698,7 +25724,7 @@
         <p:spPr>
           <a:xfrm>
             <a:off x="9552240" y="3996000"/>
-            <a:ext cx="1960200" cy="317520"/>
+            <a:ext cx="1959840" cy="317160"/>
           </a:xfrm>
           <a:prstGeom prst="rect">
             <a:avLst/>
@@ -24737,7 +25763,7 @@
                 <a:latin typeface="Calibri"/>
                 <a:ea typeface="Calibri"/>
               </a:rPr>
-              <a:t>M22-M24</a:t>
+              <a:t>M24</a:t>
             </a:r>
             <a:endParaRPr lang="fr-FR" sz="1300" b="0" u="none" strike="noStrike">
               <a:solidFill>
@@ -24759,7 +25785,7 @@
         <p:spPr>
           <a:xfrm>
             <a:off x="548640" y="4526280"/>
-            <a:ext cx="11091960" cy="866160"/>
+            <a:ext cx="11091600" cy="865800"/>
           </a:xfrm>
           <a:prstGeom prst="roundRect">
             <a:avLst>
@@ -24807,7 +25833,7 @@
         <p:spPr>
           <a:xfrm>
             <a:off x="822960" y="4526280"/>
-            <a:ext cx="10543320" cy="866160"/>
+            <a:ext cx="10542960" cy="865800"/>
           </a:xfrm>
           <a:prstGeom prst="rect">
             <a:avLst/>
@@ -24846,7 +25872,7 @@
                 <a:latin typeface="Calibri"/>
                 <a:ea typeface="Calibri"/>
               </a:rPr>
-              <a:t>Trajectoire de maturité : niveau 1 (actuel) → niveau 3 généralisé (M22 - M24)</a:t>
+              <a:t>Trajectoire de maturité : niveau 1 (actuel) → niveau 3 généralisé (M24)</a:t>
             </a:r>
             <a:endParaRPr lang="fr-FR" sz="1400" b="0" u="none" strike="noStrike">
               <a:solidFill>
@@ -24898,7 +25924,7 @@
         <p:spPr>
           <a:xfrm>
             <a:off x="548640" y="5532120"/>
-            <a:ext cx="11091960" cy="655920"/>
+            <a:ext cx="11091600" cy="655560"/>
           </a:xfrm>
           <a:prstGeom prst="roundRect">
             <a:avLst>
@@ -24953,7 +25979,7 @@
         <p:spPr>
           <a:xfrm>
             <a:off x="822960" y="5532120"/>
-            <a:ext cx="10543320" cy="655920"/>
+            <a:ext cx="10542960" cy="655560"/>
           </a:xfrm>
           <a:prstGeom prst="rect">
             <a:avLst/>
@@ -25014,7 +26040,7 @@
         <p:spPr>
           <a:xfrm>
             <a:off x="548640" y="6473880"/>
-            <a:ext cx="8684280" cy="271800"/>
+            <a:ext cx="8683920" cy="271440"/>
           </a:xfrm>
           <a:prstGeom prst="rect">
             <a:avLst/>
@@ -25075,7 +26101,7 @@
         <p:spPr>
           <a:xfrm>
             <a:off x="11003040" y="6473880"/>
-            <a:ext cx="820440" cy="271800"/>
+            <a:ext cx="820080" cy="271440"/>
           </a:xfrm>
           <a:prstGeom prst="rect">
             <a:avLst/>

</xml_diff>